<commit_message>
Live slides: livelier title slide with a subtitle
The title slide now shows 塊で覚える with a yellow marker and the
subtitle 日常英会話フレーズ in an orange pill, on a white card with
salon-coloured circles, a rounded square and sparkles around it. The
shapes are filled SVG paths, so they carry over to the .pptx.

Co-Authored-By: Claude Opus 5.5 <noreply@anthropic.com>
Claude-Session: https://claude.ai/code/session_0167kk19fU69KXrDnUiK9iq6
</commit_message>
<xml_diff>
--- a/live/daily-phrases-part2/daily-phrases-part2.pptx
+++ b/live/daily-phrases-part2/daily-phrases-part2.pptx
@@ -483,37 +483,885 @@
       <p:sp>
         <p:nvSpPr>
           <p:cNvPr id="2" name=""/>
-          <p:cNvSpPr txBox="1"/>
-          <p:nvPr/>
-        </p:nvSpPr>
-        <p:spPr>
-          <a:xfrm>
-            <a:off x="2028825" y="2838450"/>
-            <a:ext cx="9696450" cy="1152525"/>
-          </a:xfrm>
-          <a:prstGeom prst="rect">
-            <a:avLst/>
-          </a:prstGeom>
-          <a:noFill/>
-          <a:ln/>
-        </p:spPr>
-        <p:txBody>
-          <a:bodyPr wrap="square" lIns="0" tIns="0" rIns="0" bIns="0" anchor="ctr"/>
-          <a:lstStyle/>
-          <a:p>
-            <a:pPr/>
-            <a:r>
-              <a:rPr sz="6300" b="1" spc="126" kern="0">
+          <p:cNvSpPr/>
+          <p:nvPr/>
+        </p:nvSpPr>
+        <p:spPr>
+          <a:xfrm>
+            <a:off x="1238250" y="666750"/>
+            <a:ext cx="2286000" cy="2286000"/>
+          </a:xfrm>
+          <a:custGeom>
+            <a:avLst/>
+            <a:gdLst/>
+            <a:ahLst/>
+            <a:cxnLst/>
+            <a:rect l="l" t="t" r="r" b="b"/>
+            <a:pathLst>
+              <a:path w="2286000" h="2286000">
+                <a:moveTo>
+                  <a:pt x="2286000" y="1143000"/>
+                </a:moveTo>
+                <a:cubicBezTo>
+                  <a:pt x="2286000" y="1774508"/>
+                  <a:pt x="1774508" y="2286000"/>
+                  <a:pt x="1143000" y="2286000"/>
+                </a:cubicBezTo>
+                <a:cubicBezTo>
+                  <a:pt x="511492" y="2286000"/>
+                  <a:pt x="0" y="1774508"/>
+                  <a:pt x="0" y="1143000"/>
+                </a:cubicBezTo>
+                <a:cubicBezTo>
+                  <a:pt x="0" y="511492"/>
+                  <a:pt x="511492" y="0"/>
+                  <a:pt x="1143000" y="0"/>
+                </a:cubicBezTo>
+                <a:cubicBezTo>
+                  <a:pt x="1774508" y="0"/>
+                  <a:pt x="2286000" y="511492"/>
+                  <a:pt x="2286000" y="1143000"/>
+                </a:cubicBezTo>
+                <a:close/>
+              </a:path>
+            </a:pathLst>
+          </a:custGeom>
+          <a:solidFill>
+            <a:srgbClr val="A9D3F3"/>
+          </a:solidFill>
+          <a:ln/>
+        </p:spPr>
+      </p:sp>
+      <p:sp>
+        <p:nvSpPr>
+          <p:cNvPr id="3" name=""/>
+          <p:cNvSpPr/>
+          <p:nvPr/>
+        </p:nvSpPr>
+        <p:spPr>
+          <a:xfrm>
+            <a:off x="9144000" y="4191000"/>
+            <a:ext cx="1809750" cy="1809750"/>
+          </a:xfrm>
+          <a:custGeom>
+            <a:avLst/>
+            <a:gdLst/>
+            <a:ahLst/>
+            <a:cxnLst/>
+            <a:rect l="l" t="t" r="r" b="b"/>
+            <a:pathLst>
+              <a:path w="1809750" h="1809750">
+                <a:moveTo>
+                  <a:pt x="457200" y="0"/>
+                </a:moveTo>
+                <a:lnTo>
+                  <a:pt x="1352550" y="0"/>
+                </a:lnTo>
+                <a:cubicBezTo>
+                  <a:pt x="1604963" y="0"/>
+                  <a:pt x="1809750" y="204787"/>
+                  <a:pt x="1809750" y="457200"/>
+                </a:cubicBezTo>
+                <a:lnTo>
+                  <a:pt x="1809750" y="1352550"/>
+                </a:lnTo>
+                <a:cubicBezTo>
+                  <a:pt x="1809750" y="1604963"/>
+                  <a:pt x="1604963" y="1809750"/>
+                  <a:pt x="1352550" y="1809750"/>
+                </a:cubicBezTo>
+                <a:lnTo>
+                  <a:pt x="457200" y="1809750"/>
+                </a:lnTo>
+                <a:cubicBezTo>
+                  <a:pt x="204787" y="1809750"/>
+                  <a:pt x="0" y="1604963"/>
+                  <a:pt x="0" y="1352550"/>
+                </a:cubicBezTo>
+                <a:lnTo>
+                  <a:pt x="0" y="457200"/>
+                </a:lnTo>
+                <a:cubicBezTo>
+                  <a:pt x="0" y="204787"/>
+                  <a:pt x="204787" y="0"/>
+                  <a:pt x="457200" y="0"/>
+                </a:cubicBezTo>
+                <a:close/>
+              </a:path>
+            </a:pathLst>
+          </a:custGeom>
+          <a:solidFill>
+            <a:srgbClr val="FFD3DD"/>
+          </a:solidFill>
+          <a:ln/>
+        </p:spPr>
+      </p:sp>
+      <p:sp>
+        <p:nvSpPr>
+          <p:cNvPr id="4" name=""/>
+          <p:cNvSpPr/>
+          <p:nvPr/>
+        </p:nvSpPr>
+        <p:spPr>
+          <a:xfrm>
+            <a:off x="10039350" y="895350"/>
+            <a:ext cx="1066800" cy="1066800"/>
+          </a:xfrm>
+          <a:custGeom>
+            <a:avLst/>
+            <a:gdLst/>
+            <a:ahLst/>
+            <a:cxnLst/>
+            <a:rect l="l" t="t" r="r" b="b"/>
+            <a:pathLst>
+              <a:path w="1066800" h="1066800">
+                <a:moveTo>
+                  <a:pt x="1066800" y="533400"/>
+                </a:moveTo>
+                <a:cubicBezTo>
+                  <a:pt x="1066800" y="827723"/>
+                  <a:pt x="827723" y="1066800"/>
+                  <a:pt x="533400" y="1066800"/>
+                </a:cubicBezTo>
+                <a:cubicBezTo>
+                  <a:pt x="239077" y="1066800"/>
+                  <a:pt x="0" y="827723"/>
+                  <a:pt x="0" y="533400"/>
+                </a:cubicBezTo>
+                <a:cubicBezTo>
+                  <a:pt x="0" y="239077"/>
+                  <a:pt x="239077" y="0"/>
+                  <a:pt x="533400" y="0"/>
+                </a:cubicBezTo>
+                <a:cubicBezTo>
+                  <a:pt x="827723" y="0"/>
+                  <a:pt x="1066800" y="239077"/>
+                  <a:pt x="1066800" y="533400"/>
+                </a:cubicBezTo>
+                <a:close/>
+              </a:path>
+            </a:pathLst>
+          </a:custGeom>
+          <a:solidFill>
+            <a:srgbClr val="FFD966"/>
+          </a:solidFill>
+          <a:ln/>
+        </p:spPr>
+      </p:sp>
+      <p:sp>
+        <p:nvSpPr>
+          <p:cNvPr id="5" name=""/>
+          <p:cNvSpPr/>
+          <p:nvPr/>
+        </p:nvSpPr>
+        <p:spPr>
+          <a:xfrm>
+            <a:off x="1247775" y="4772025"/>
+            <a:ext cx="838200" cy="838200"/>
+          </a:xfrm>
+          <a:custGeom>
+            <a:avLst/>
+            <a:gdLst/>
+            <a:ahLst/>
+            <a:cxnLst/>
+            <a:rect l="l" t="t" r="r" b="b"/>
+            <a:pathLst>
+              <a:path w="838200" h="838200">
+                <a:moveTo>
+                  <a:pt x="838200" y="419100"/>
+                </a:moveTo>
+                <a:cubicBezTo>
+                  <a:pt x="838200" y="650557"/>
+                  <a:pt x="650558" y="838200"/>
+                  <a:pt x="419100" y="838200"/>
+                </a:cubicBezTo>
+                <a:cubicBezTo>
+                  <a:pt x="187642" y="838200"/>
+                  <a:pt x="0" y="650557"/>
+                  <a:pt x="0" y="419100"/>
+                </a:cubicBezTo>
+                <a:cubicBezTo>
+                  <a:pt x="0" y="187643"/>
+                  <a:pt x="187642" y="0"/>
+                  <a:pt x="419100" y="0"/>
+                </a:cubicBezTo>
+                <a:cubicBezTo>
+                  <a:pt x="650558" y="0"/>
+                  <a:pt x="838200" y="187643"/>
+                  <a:pt x="838200" y="419100"/>
+                </a:cubicBezTo>
+                <a:close/>
+              </a:path>
+            </a:pathLst>
+          </a:custGeom>
+          <a:solidFill>
+            <a:srgbClr val="FF9C6E"/>
+          </a:solidFill>
+          <a:ln/>
+        </p:spPr>
+      </p:sp>
+      <p:sp>
+        <p:nvSpPr>
+          <p:cNvPr id="6" name=""/>
+          <p:cNvSpPr/>
+          <p:nvPr/>
+        </p:nvSpPr>
+        <p:spPr>
+          <a:xfrm>
+            <a:off x="771525" y="3295650"/>
+            <a:ext cx="266700" cy="266700"/>
+          </a:xfrm>
+          <a:custGeom>
+            <a:avLst/>
+            <a:gdLst/>
+            <a:ahLst/>
+            <a:cxnLst/>
+            <a:rect l="l" t="t" r="r" b="b"/>
+            <a:pathLst>
+              <a:path w="266700" h="266700">
+                <a:moveTo>
+                  <a:pt x="266700" y="133350"/>
+                </a:moveTo>
+                <a:cubicBezTo>
+                  <a:pt x="266700" y="206692"/>
+                  <a:pt x="206693" y="266700"/>
+                  <a:pt x="133350" y="266700"/>
+                </a:cubicBezTo>
+                <a:cubicBezTo>
+                  <a:pt x="60007" y="266700"/>
+                  <a:pt x="0" y="206692"/>
+                  <a:pt x="0" y="133350"/>
+                </a:cubicBezTo>
+                <a:cubicBezTo>
+                  <a:pt x="0" y="60008"/>
+                  <a:pt x="60007" y="0"/>
+                  <a:pt x="133350" y="0"/>
+                </a:cubicBezTo>
+                <a:cubicBezTo>
+                  <a:pt x="206693" y="0"/>
+                  <a:pt x="266700" y="60008"/>
+                  <a:pt x="266700" y="133350"/>
+                </a:cubicBezTo>
+                <a:close/>
+              </a:path>
+            </a:pathLst>
+          </a:custGeom>
+          <a:solidFill>
+            <a:srgbClr val="FF9DB4"/>
+          </a:solidFill>
+          <a:ln/>
+        </p:spPr>
+      </p:sp>
+      <p:sp>
+        <p:nvSpPr>
+          <p:cNvPr id="7" name=""/>
+          <p:cNvSpPr/>
+          <p:nvPr/>
+        </p:nvSpPr>
+        <p:spPr>
+          <a:xfrm>
+            <a:off x="11268075" y="3505200"/>
+            <a:ext cx="228600" cy="228600"/>
+          </a:xfrm>
+          <a:custGeom>
+            <a:avLst/>
+            <a:gdLst/>
+            <a:ahLst/>
+            <a:cxnLst/>
+            <a:rect l="l" t="t" r="r" b="b"/>
+            <a:pathLst>
+              <a:path w="228600" h="228600">
+                <a:moveTo>
+                  <a:pt x="228600" y="114300"/>
+                </a:moveTo>
+                <a:cubicBezTo>
+                  <a:pt x="228600" y="177165"/>
+                  <a:pt x="177165" y="228600"/>
+                  <a:pt x="114300" y="228600"/>
+                </a:cubicBezTo>
+                <a:cubicBezTo>
+                  <a:pt x="51435" y="228600"/>
+                  <a:pt x="0" y="177165"/>
+                  <a:pt x="0" y="114300"/>
+                </a:cubicBezTo>
+                <a:cubicBezTo>
+                  <a:pt x="0" y="51435"/>
+                  <a:pt x="51435" y="0"/>
+                  <a:pt x="114300" y="0"/>
+                </a:cubicBezTo>
+                <a:cubicBezTo>
+                  <a:pt x="177165" y="0"/>
+                  <a:pt x="228600" y="51435"/>
+                  <a:pt x="228600" y="114300"/>
+                </a:cubicBezTo>
+                <a:close/>
+              </a:path>
+            </a:pathLst>
+          </a:custGeom>
+          <a:solidFill>
+            <a:srgbClr val="7DBDEB"/>
+          </a:solidFill>
+          <a:ln/>
+        </p:spPr>
+      </p:sp>
+      <p:sp>
+        <p:nvSpPr>
+          <p:cNvPr id="8" name=""/>
+          <p:cNvSpPr/>
+          <p:nvPr/>
+        </p:nvSpPr>
+        <p:spPr>
+          <a:xfrm>
+            <a:off x="5619750" y="809625"/>
+            <a:ext cx="190500" cy="190500"/>
+          </a:xfrm>
+          <a:custGeom>
+            <a:avLst/>
+            <a:gdLst/>
+            <a:ahLst/>
+            <a:cxnLst/>
+            <a:rect l="l" t="t" r="r" b="b"/>
+            <a:pathLst>
+              <a:path w="190500" h="190500">
+                <a:moveTo>
+                  <a:pt x="190500" y="95250"/>
+                </a:moveTo>
+                <a:cubicBezTo>
+                  <a:pt x="190500" y="147637"/>
+                  <a:pt x="147637" y="190500"/>
+                  <a:pt x="95250" y="190500"/>
+                </a:cubicBezTo>
+                <a:cubicBezTo>
+                  <a:pt x="42863" y="190500"/>
+                  <a:pt x="0" y="147637"/>
+                  <a:pt x="0" y="95250"/>
+                </a:cubicBezTo>
+                <a:cubicBezTo>
+                  <a:pt x="0" y="42863"/>
+                  <a:pt x="42863" y="0"/>
+                  <a:pt x="95250" y="0"/>
+                </a:cubicBezTo>
+                <a:cubicBezTo>
+                  <a:pt x="147637" y="0"/>
+                  <a:pt x="190500" y="42863"/>
+                  <a:pt x="190500" y="95250"/>
+                </a:cubicBezTo>
+                <a:close/>
+              </a:path>
+            </a:pathLst>
+          </a:custGeom>
+          <a:solidFill>
+            <a:srgbClr val="FFC94A"/>
+          </a:solidFill>
+          <a:ln/>
+        </p:spPr>
+      </p:sp>
+      <p:sp>
+        <p:nvSpPr>
+          <p:cNvPr id="9" name=""/>
+          <p:cNvSpPr/>
+          <p:nvPr/>
+        </p:nvSpPr>
+        <p:spPr>
+          <a:xfrm>
+            <a:off x="9448800" y="781050"/>
+            <a:ext cx="152400" cy="152400"/>
+          </a:xfrm>
+          <a:custGeom>
+            <a:avLst/>
+            <a:gdLst/>
+            <a:ahLst/>
+            <a:cxnLst/>
+            <a:rect l="l" t="t" r="r" b="b"/>
+            <a:pathLst>
+              <a:path w="152400" h="152400">
+                <a:moveTo>
+                  <a:pt x="152400" y="76200"/>
+                </a:moveTo>
+                <a:cubicBezTo>
+                  <a:pt x="152400" y="118110"/>
+                  <a:pt x="118110" y="152400"/>
+                  <a:pt x="76200" y="152400"/>
+                </a:cubicBezTo>
+                <a:cubicBezTo>
+                  <a:pt x="34290" y="152400"/>
+                  <a:pt x="0" y="118110"/>
+                  <a:pt x="0" y="76200"/>
+                </a:cubicBezTo>
+                <a:cubicBezTo>
+                  <a:pt x="0" y="34290"/>
+                  <a:pt x="34290" y="0"/>
+                  <a:pt x="76200" y="0"/>
+                </a:cubicBezTo>
+                <a:cubicBezTo>
+                  <a:pt x="118110" y="0"/>
+                  <a:pt x="152400" y="34290"/>
+                  <a:pt x="152400" y="76200"/>
+                </a:cubicBezTo>
+                <a:close/>
+              </a:path>
+            </a:pathLst>
+          </a:custGeom>
+          <a:solidFill>
+            <a:srgbClr val="FF8A57"/>
+          </a:solidFill>
+          <a:ln/>
+        </p:spPr>
+      </p:sp>
+      <p:sp>
+        <p:nvSpPr>
+          <p:cNvPr id="10" name=""/>
+          <p:cNvSpPr/>
+          <p:nvPr/>
+        </p:nvSpPr>
+        <p:spPr>
+          <a:xfrm>
+            <a:off x="7124700" y="5981700"/>
+            <a:ext cx="228600" cy="228600"/>
+          </a:xfrm>
+          <a:custGeom>
+            <a:avLst/>
+            <a:gdLst/>
+            <a:ahLst/>
+            <a:cxnLst/>
+            <a:rect l="l" t="t" r="r" b="b"/>
+            <a:pathLst>
+              <a:path w="228600" h="228600">
+                <a:moveTo>
+                  <a:pt x="228600" y="114300"/>
+                </a:moveTo>
+                <a:cubicBezTo>
+                  <a:pt x="228600" y="177165"/>
+                  <a:pt x="177165" y="228600"/>
+                  <a:pt x="114300" y="228600"/>
+                </a:cubicBezTo>
+                <a:cubicBezTo>
+                  <a:pt x="51435" y="228600"/>
+                  <a:pt x="0" y="177165"/>
+                  <a:pt x="0" y="114300"/>
+                </a:cubicBezTo>
+                <a:cubicBezTo>
+                  <a:pt x="0" y="51435"/>
+                  <a:pt x="51435" y="0"/>
+                  <a:pt x="114300" y="0"/>
+                </a:cubicBezTo>
+                <a:cubicBezTo>
+                  <a:pt x="177165" y="0"/>
+                  <a:pt x="228600" y="51435"/>
+                  <a:pt x="228600" y="114300"/>
+                </a:cubicBezTo>
+                <a:close/>
+              </a:path>
+            </a:pathLst>
+          </a:custGeom>
+          <a:solidFill>
+            <a:srgbClr val="FF9DB4"/>
+          </a:solidFill>
+          <a:ln/>
+        </p:spPr>
+      </p:sp>
+      <p:sp>
+        <p:nvSpPr>
+          <p:cNvPr id="11" name=""/>
+          <p:cNvSpPr/>
+          <p:nvPr/>
+        </p:nvSpPr>
+        <p:spPr>
+          <a:xfrm>
+            <a:off x="3914775" y="6124575"/>
+            <a:ext cx="171450" cy="171450"/>
+          </a:xfrm>
+          <a:custGeom>
+            <a:avLst/>
+            <a:gdLst/>
+            <a:ahLst/>
+            <a:cxnLst/>
+            <a:rect l="l" t="t" r="r" b="b"/>
+            <a:pathLst>
+              <a:path w="171450" h="171450">
+                <a:moveTo>
+                  <a:pt x="171450" y="85725"/>
+                </a:moveTo>
+                <a:cubicBezTo>
+                  <a:pt x="171450" y="133350"/>
+                  <a:pt x="133350" y="171450"/>
+                  <a:pt x="85725" y="171450"/>
+                </a:cubicBezTo>
+                <a:cubicBezTo>
+                  <a:pt x="38100" y="171450"/>
+                  <a:pt x="0" y="133350"/>
+                  <a:pt x="0" y="85725"/>
+                </a:cubicBezTo>
+                <a:cubicBezTo>
+                  <a:pt x="0" y="38100"/>
+                  <a:pt x="38100" y="0"/>
+                  <a:pt x="85725" y="0"/>
+                </a:cubicBezTo>
+                <a:cubicBezTo>
+                  <a:pt x="133350" y="0"/>
+                  <a:pt x="171450" y="38100"/>
+                  <a:pt x="171450" y="85725"/>
+                </a:cubicBezTo>
+                <a:close/>
+              </a:path>
+            </a:pathLst>
+          </a:custGeom>
+          <a:solidFill>
+            <a:srgbClr val="7DBDEB"/>
+          </a:solidFill>
+          <a:ln/>
+        </p:spPr>
+      </p:sp>
+      <p:sp>
+        <p:nvSpPr>
+          <p:cNvPr id="12" name=""/>
+          <p:cNvSpPr/>
+          <p:nvPr/>
+        </p:nvSpPr>
+        <p:spPr>
+          <a:xfrm>
+            <a:off x="2000250" y="1504950"/>
+            <a:ext cx="8191500" cy="3810000"/>
+          </a:xfrm>
+          <a:prstGeom prst="roundRect">
+            <a:avLst>
+              <a:gd name="adj" fmla="val 11000"/>
+            </a:avLst>
+          </a:prstGeom>
+          <a:solidFill>
+            <a:srgbClr val="FFFFFF"/>
+          </a:solidFill>
+          <a:ln/>
+          <a:effectLst>
+            <a:outerShdw sx="100000" sy="100000" kx="0" ky="0" algn="bl" rotWithShape="0" blurRad="152400" dist="50800" dir="5400000">
+              <a:srgbClr val="22304A">
+                <a:alpha val="10000"/>
+              </a:srgbClr>
+            </a:outerShdw>
+          </a:effectLst>
+        </p:spPr>
+      </p:sp>
+      <p:sp>
+        <p:nvSpPr>
+          <p:cNvPr id="13" name=""/>
+          <p:cNvSpPr/>
+          <p:nvPr/>
+        </p:nvSpPr>
+        <p:spPr>
+          <a:xfrm>
+            <a:off x="3009900" y="3133725"/>
+            <a:ext cx="6172200" cy="381000"/>
+          </a:xfrm>
+          <a:prstGeom prst="roundRect">
+            <a:avLst>
+              <a:gd name="adj" fmla="val 30000"/>
+            </a:avLst>
+          </a:prstGeom>
+          <a:solidFill>
+            <a:srgbClr val="FFD966"/>
+          </a:solidFill>
+          <a:ln/>
+        </p:spPr>
+      </p:sp>
+      <p:sp>
+        <p:nvSpPr>
+          <p:cNvPr id="14" name=""/>
+          <p:cNvSpPr txBox="1"/>
+          <p:nvPr/>
+        </p:nvSpPr>
+        <p:spPr>
+          <a:xfrm>
+            <a:off x="3143250" y="2076450"/>
+            <a:ext cx="7134225" cy="1657350"/>
+          </a:xfrm>
+          <a:prstGeom prst="rect">
+            <a:avLst/>
+          </a:prstGeom>
+          <a:noFill/>
+          <a:ln/>
+        </p:spPr>
+        <p:txBody>
+          <a:bodyPr wrap="square" lIns="0" tIns="0" rIns="0" bIns="0" anchor="ctr"/>
+          <a:lstStyle/>
+          <a:p>
+            <a:pPr/>
+            <a:r>
+              <a:rPr sz="9000" b="1" spc="360" kern="0">
                 <a:solidFill>
                   <a:srgbClr val="1A2238"/>
                 </a:solidFill>
                 <a:latin typeface="Noto Sans JP"/>
                 <a:ea typeface="Noto Sans JP"/>
               </a:rPr>
-              <a:t>塊で覚える日常英会話</a:t>
-            </a:r>
-          </a:p>
-        </p:txBody>
+              <a:t>塊で覚える</a:t>
+            </a:r>
+          </a:p>
+        </p:txBody>
+      </p:sp>
+      <p:sp>
+        <p:nvSpPr>
+          <p:cNvPr id="15" name=""/>
+          <p:cNvSpPr/>
+          <p:nvPr/>
+        </p:nvSpPr>
+        <p:spPr>
+          <a:xfrm>
+            <a:off x="3838575" y="3800475"/>
+            <a:ext cx="4524375" cy="800100"/>
+          </a:xfrm>
+          <a:prstGeom prst="roundRect">
+            <a:avLst>
+              <a:gd name="adj" fmla="val 50000"/>
+            </a:avLst>
+          </a:prstGeom>
+          <a:solidFill>
+            <a:srgbClr val="F0521E"/>
+          </a:solidFill>
+          <a:ln/>
+        </p:spPr>
+      </p:sp>
+      <p:sp>
+        <p:nvSpPr>
+          <p:cNvPr id="16" name=""/>
+          <p:cNvSpPr txBox="1"/>
+          <p:nvPr/>
+        </p:nvSpPr>
+        <p:spPr>
+          <a:xfrm>
+            <a:off x="4257675" y="3914775"/>
+            <a:ext cx="4581525" cy="552450"/>
+          </a:xfrm>
+          <a:prstGeom prst="rect">
+            <a:avLst/>
+          </a:prstGeom>
+          <a:noFill/>
+          <a:ln/>
+        </p:spPr>
+        <p:txBody>
+          <a:bodyPr wrap="square" lIns="0" tIns="0" rIns="0" bIns="0" anchor="ctr"/>
+          <a:lstStyle/>
+          <a:p>
+            <a:pPr/>
+            <a:r>
+              <a:rPr sz="3000" b="1" spc="240" kern="0">
+                <a:solidFill>
+                  <a:srgbClr val="FFFFFF"/>
+                </a:solidFill>
+                <a:latin typeface="Noto Sans JP"/>
+                <a:ea typeface="Noto Sans JP"/>
+              </a:rPr>
+              <a:t>日常英会話フレーズ</a:t>
+            </a:r>
+          </a:p>
+        </p:txBody>
+      </p:sp>
+      <p:sp>
+        <p:nvSpPr>
+          <p:cNvPr id="17" name=""/>
+          <p:cNvSpPr/>
+          <p:nvPr/>
+        </p:nvSpPr>
+        <p:spPr>
+          <a:xfrm>
+            <a:off x="9696450" y="1352550"/>
+            <a:ext cx="647700" cy="647700"/>
+          </a:xfrm>
+          <a:custGeom>
+            <a:avLst/>
+            <a:gdLst/>
+            <a:ahLst/>
+            <a:cxnLst/>
+            <a:rect l="l" t="t" r="r" b="b"/>
+            <a:pathLst>
+              <a:path w="647700" h="647700">
+                <a:moveTo>
+                  <a:pt x="323850" y="0"/>
+                </a:moveTo>
+                <a:cubicBezTo>
+                  <a:pt x="369570" y="278130"/>
+                  <a:pt x="369570" y="278130"/>
+                  <a:pt x="647700" y="323850"/>
+                </a:cubicBezTo>
+                <a:cubicBezTo>
+                  <a:pt x="369570" y="369570"/>
+                  <a:pt x="369570" y="369570"/>
+                  <a:pt x="323850" y="647700"/>
+                </a:cubicBezTo>
+                <a:cubicBezTo>
+                  <a:pt x="278130" y="369570"/>
+                  <a:pt x="278130" y="369570"/>
+                  <a:pt x="0" y="323850"/>
+                </a:cubicBezTo>
+                <a:cubicBezTo>
+                  <a:pt x="278130" y="278130"/>
+                  <a:pt x="278130" y="278130"/>
+                  <a:pt x="323850" y="0"/>
+                </a:cubicBezTo>
+                <a:close/>
+              </a:path>
+            </a:pathLst>
+          </a:custGeom>
+          <a:solidFill>
+            <a:srgbClr val="F0521E"/>
+          </a:solidFill>
+          <a:ln/>
+        </p:spPr>
+      </p:sp>
+      <p:sp>
+        <p:nvSpPr>
+          <p:cNvPr id="18" name=""/>
+          <p:cNvSpPr/>
+          <p:nvPr/>
+        </p:nvSpPr>
+        <p:spPr>
+          <a:xfrm>
+            <a:off x="2000250" y="5086350"/>
+            <a:ext cx="495300" cy="495300"/>
+          </a:xfrm>
+          <a:custGeom>
+            <a:avLst/>
+            <a:gdLst/>
+            <a:ahLst/>
+            <a:cxnLst/>
+            <a:rect l="l" t="t" r="r" b="b"/>
+            <a:pathLst>
+              <a:path w="495300" h="495300">
+                <a:moveTo>
+                  <a:pt x="247650" y="0"/>
+                </a:moveTo>
+                <a:cubicBezTo>
+                  <a:pt x="281940" y="213360"/>
+                  <a:pt x="281940" y="213360"/>
+                  <a:pt x="495300" y="247650"/>
+                </a:cubicBezTo>
+                <a:cubicBezTo>
+                  <a:pt x="281940" y="281940"/>
+                  <a:pt x="281940" y="281940"/>
+                  <a:pt x="247650" y="495300"/>
+                </a:cubicBezTo>
+                <a:cubicBezTo>
+                  <a:pt x="213360" y="281940"/>
+                  <a:pt x="213360" y="281940"/>
+                  <a:pt x="0" y="247650"/>
+                </a:cubicBezTo>
+                <a:cubicBezTo>
+                  <a:pt x="213360" y="213360"/>
+                  <a:pt x="213360" y="213360"/>
+                  <a:pt x="247650" y="0"/>
+                </a:cubicBezTo>
+                <a:close/>
+              </a:path>
+            </a:pathLst>
+          </a:custGeom>
+          <a:solidFill>
+            <a:srgbClr val="FFC94A"/>
+          </a:solidFill>
+          <a:ln/>
+        </p:spPr>
+      </p:sp>
+      <p:sp>
+        <p:nvSpPr>
+          <p:cNvPr id="19" name=""/>
+          <p:cNvSpPr/>
+          <p:nvPr/>
+        </p:nvSpPr>
+        <p:spPr>
+          <a:xfrm>
+            <a:off x="11144250" y="5238750"/>
+            <a:ext cx="304800" cy="304800"/>
+          </a:xfrm>
+          <a:custGeom>
+            <a:avLst/>
+            <a:gdLst/>
+            <a:ahLst/>
+            <a:cxnLst/>
+            <a:rect l="l" t="t" r="r" b="b"/>
+            <a:pathLst>
+              <a:path w="304800" h="304800">
+                <a:moveTo>
+                  <a:pt x="152400" y="0"/>
+                </a:moveTo>
+                <a:cubicBezTo>
+                  <a:pt x="173355" y="131445"/>
+                  <a:pt x="173355" y="131445"/>
+                  <a:pt x="304800" y="152400"/>
+                </a:cubicBezTo>
+                <a:cubicBezTo>
+                  <a:pt x="173355" y="173355"/>
+                  <a:pt x="173355" y="173355"/>
+                  <a:pt x="152400" y="304800"/>
+                </a:cubicBezTo>
+                <a:cubicBezTo>
+                  <a:pt x="131445" y="173355"/>
+                  <a:pt x="131445" y="173355"/>
+                  <a:pt x="0" y="152400"/>
+                </a:cubicBezTo>
+                <a:cubicBezTo>
+                  <a:pt x="131445" y="131445"/>
+                  <a:pt x="131445" y="131445"/>
+                  <a:pt x="152400" y="0"/>
+                </a:cubicBezTo>
+                <a:close/>
+              </a:path>
+            </a:pathLst>
+          </a:custGeom>
+          <a:solidFill>
+            <a:srgbClr val="7DBDEB"/>
+          </a:solidFill>
+          <a:ln/>
+        </p:spPr>
+      </p:sp>
+      <p:sp>
+        <p:nvSpPr>
+          <p:cNvPr id="20" name=""/>
+          <p:cNvSpPr/>
+          <p:nvPr/>
+        </p:nvSpPr>
+        <p:spPr>
+          <a:xfrm>
+            <a:off x="1009650" y="2095500"/>
+            <a:ext cx="304800" cy="304800"/>
+          </a:xfrm>
+          <a:custGeom>
+            <a:avLst/>
+            <a:gdLst/>
+            <a:ahLst/>
+            <a:cxnLst/>
+            <a:rect l="l" t="t" r="r" b="b"/>
+            <a:pathLst>
+              <a:path w="304800" h="304800">
+                <a:moveTo>
+                  <a:pt x="152400" y="0"/>
+                </a:moveTo>
+                <a:cubicBezTo>
+                  <a:pt x="173355" y="131445"/>
+                  <a:pt x="173355" y="131445"/>
+                  <a:pt x="304800" y="152400"/>
+                </a:cubicBezTo>
+                <a:cubicBezTo>
+                  <a:pt x="173355" y="173355"/>
+                  <a:pt x="173355" y="173355"/>
+                  <a:pt x="152400" y="304800"/>
+                </a:cubicBezTo>
+                <a:cubicBezTo>
+                  <a:pt x="131445" y="173355"/>
+                  <a:pt x="131445" y="173355"/>
+                  <a:pt x="0" y="152400"/>
+                </a:cubicBezTo>
+                <a:cubicBezTo>
+                  <a:pt x="131445" y="131445"/>
+                  <a:pt x="131445" y="131445"/>
+                  <a:pt x="152400" y="0"/>
+                </a:cubicBezTo>
+                <a:close/>
+              </a:path>
+            </a:pathLst>
+          </a:custGeom>
+          <a:solidFill>
+            <a:srgbClr val="FF9DB4"/>
+          </a:solidFill>
+          <a:ln/>
+        </p:spPr>
       </p:sp>
     </p:spTree>
   </p:cSld>

</xml_diff>

<commit_message>
Live slides: Okinawa beach title slide
The title card now sits on an Okinawa scene, since the live is streamed
from Okinawa: sky, sun and clouds, layered sea, white sand, a palm tree,
red and pink hibiscus, and a ミンサー織り band (groups of five and four
squares) along the top. Everything is filled SVG paths, so it carries
over to the .pptx.

Co-Authored-By: Claude Opus 5.5 <noreply@anthropic.com>
Claude-Session: https://claude.ai/code/session_0167kk19fU69KXrDnUiK9iq6
</commit_message>
<xml_diff>
--- a/live/daily-phrases-part2/daily-phrases-part2.pptx
+++ b/live/daily-phrases-part2/daily-phrases-part2.pptx
@@ -462,7 +462,7 @@
     <p:bg>
       <p:bgPr>
         <a:solidFill>
-          <a:srgbClr val="EAF2FB"/>
+          <a:srgbClr val="E3F4FA"/>
         </a:solidFill>
       </p:bgPr>
     </p:bg>
@@ -488,8 +488,8 @@
         </p:nvSpPr>
         <p:spPr>
           <a:xfrm>
-            <a:off x="1238250" y="666750"/>
-            <a:ext cx="2286000" cy="2286000"/>
+            <a:off x="0" y="0"/>
+            <a:ext cx="12192000" cy="285750"/>
           </a:xfrm>
           <a:custGeom>
             <a:avLst/>
@@ -498,50 +498,925 @@
             <a:cxnLst/>
             <a:rect l="l" t="t" r="r" b="b"/>
             <a:pathLst>
-              <a:path w="2286000" h="2286000">
+              <a:path w="12192000" h="285750">
                 <a:moveTo>
-                  <a:pt x="2286000" y="1143000"/>
+                  <a:pt x="0" y="0"/>
+                </a:moveTo>
+                <a:lnTo>
+                  <a:pt x="12192000" y="0"/>
+                </a:lnTo>
+                <a:lnTo>
+                  <a:pt x="12192000" y="285750"/>
+                </a:lnTo>
+                <a:lnTo>
+                  <a:pt x="0" y="285750"/>
+                </a:lnTo>
+                <a:close/>
+              </a:path>
+            </a:pathLst>
+          </a:custGeom>
+          <a:solidFill>
+            <a:srgbClr val="24488A"/>
+          </a:solidFill>
+          <a:ln/>
+        </p:spPr>
+      </p:sp>
+      <p:sp>
+        <p:nvSpPr>
+          <p:cNvPr id="3" name=""/>
+          <p:cNvSpPr/>
+          <p:nvPr/>
+        </p:nvSpPr>
+        <p:spPr>
+          <a:xfrm>
+            <a:off x="171450" y="85725"/>
+            <a:ext cx="11887200" cy="114300"/>
+          </a:xfrm>
+          <a:custGeom>
+            <a:avLst/>
+            <a:gdLst/>
+            <a:ahLst/>
+            <a:cxnLst/>
+            <a:rect l="l" t="t" r="r" b="b"/>
+            <a:pathLst>
+              <a:path w="11887200" h="114300">
+                <a:moveTo>
+                  <a:pt x="0" y="0"/>
+                </a:moveTo>
+                <a:lnTo>
+                  <a:pt x="114300" y="0"/>
+                </a:lnTo>
+                <a:lnTo>
+                  <a:pt x="114300" y="114300"/>
+                </a:lnTo>
+                <a:lnTo>
+                  <a:pt x="0" y="114300"/>
+                </a:lnTo>
+                <a:close/>
+                <a:moveTo>
+                  <a:pt x="152400" y="0"/>
+                </a:moveTo>
+                <a:lnTo>
+                  <a:pt x="266700" y="0"/>
+                </a:lnTo>
+                <a:lnTo>
+                  <a:pt x="266700" y="114300"/>
+                </a:lnTo>
+                <a:lnTo>
+                  <a:pt x="152400" y="114300"/>
+                </a:lnTo>
+                <a:close/>
+                <a:moveTo>
+                  <a:pt x="304800" y="0"/>
+                </a:moveTo>
+                <a:lnTo>
+                  <a:pt x="419100" y="0"/>
+                </a:lnTo>
+                <a:lnTo>
+                  <a:pt x="419100" y="114300"/>
+                </a:lnTo>
+                <a:lnTo>
+                  <a:pt x="304800" y="114300"/>
+                </a:lnTo>
+                <a:close/>
+                <a:moveTo>
+                  <a:pt x="457200" y="0"/>
+                </a:moveTo>
+                <a:lnTo>
+                  <a:pt x="571500" y="0"/>
+                </a:lnTo>
+                <a:lnTo>
+                  <a:pt x="571500" y="114300"/>
+                </a:lnTo>
+                <a:lnTo>
+                  <a:pt x="457200" y="114300"/>
+                </a:lnTo>
+                <a:close/>
+                <a:moveTo>
+                  <a:pt x="609600" y="0"/>
+                </a:moveTo>
+                <a:lnTo>
+                  <a:pt x="723900" y="0"/>
+                </a:lnTo>
+                <a:lnTo>
+                  <a:pt x="723900" y="114300"/>
+                </a:lnTo>
+                <a:lnTo>
+                  <a:pt x="609600" y="114300"/>
+                </a:lnTo>
+                <a:close/>
+                <a:moveTo>
+                  <a:pt x="952500" y="0"/>
+                </a:moveTo>
+                <a:lnTo>
+                  <a:pt x="1066800" y="0"/>
+                </a:lnTo>
+                <a:lnTo>
+                  <a:pt x="1066800" y="114300"/>
+                </a:lnTo>
+                <a:lnTo>
+                  <a:pt x="952500" y="114300"/>
+                </a:lnTo>
+                <a:close/>
+                <a:moveTo>
+                  <a:pt x="1104900" y="0"/>
+                </a:moveTo>
+                <a:lnTo>
+                  <a:pt x="1219200" y="0"/>
+                </a:lnTo>
+                <a:lnTo>
+                  <a:pt x="1219200" y="114300"/>
+                </a:lnTo>
+                <a:lnTo>
+                  <a:pt x="1104900" y="114300"/>
+                </a:lnTo>
+                <a:close/>
+                <a:moveTo>
+                  <a:pt x="1257300" y="0"/>
+                </a:moveTo>
+                <a:lnTo>
+                  <a:pt x="1371600" y="0"/>
+                </a:lnTo>
+                <a:lnTo>
+                  <a:pt x="1371600" y="114300"/>
+                </a:lnTo>
+                <a:lnTo>
+                  <a:pt x="1257300" y="114300"/>
+                </a:lnTo>
+                <a:close/>
+                <a:moveTo>
+                  <a:pt x="1409700" y="0"/>
+                </a:moveTo>
+                <a:lnTo>
+                  <a:pt x="1524000" y="0"/>
+                </a:lnTo>
+                <a:lnTo>
+                  <a:pt x="1524000" y="114300"/>
+                </a:lnTo>
+                <a:lnTo>
+                  <a:pt x="1409700" y="114300"/>
+                </a:lnTo>
+                <a:close/>
+                <a:moveTo>
+                  <a:pt x="1752600" y="0"/>
+                </a:moveTo>
+                <a:lnTo>
+                  <a:pt x="1866900" y="0"/>
+                </a:lnTo>
+                <a:lnTo>
+                  <a:pt x="1866900" y="114300"/>
+                </a:lnTo>
+                <a:lnTo>
+                  <a:pt x="1752600" y="114300"/>
+                </a:lnTo>
+                <a:close/>
+                <a:moveTo>
+                  <a:pt x="1905000" y="0"/>
+                </a:moveTo>
+                <a:lnTo>
+                  <a:pt x="2019300" y="0"/>
+                </a:lnTo>
+                <a:lnTo>
+                  <a:pt x="2019300" y="114300"/>
+                </a:lnTo>
+                <a:lnTo>
+                  <a:pt x="1905000" y="114300"/>
+                </a:lnTo>
+                <a:close/>
+                <a:moveTo>
+                  <a:pt x="2057400" y="0"/>
+                </a:moveTo>
+                <a:lnTo>
+                  <a:pt x="2171700" y="0"/>
+                </a:lnTo>
+                <a:lnTo>
+                  <a:pt x="2171700" y="114300"/>
+                </a:lnTo>
+                <a:lnTo>
+                  <a:pt x="2057400" y="114300"/>
+                </a:lnTo>
+                <a:close/>
+                <a:moveTo>
+                  <a:pt x="2209800" y="0"/>
+                </a:moveTo>
+                <a:lnTo>
+                  <a:pt x="2324100" y="0"/>
+                </a:lnTo>
+                <a:lnTo>
+                  <a:pt x="2324100" y="114300"/>
+                </a:lnTo>
+                <a:lnTo>
+                  <a:pt x="2209800" y="114300"/>
+                </a:lnTo>
+                <a:close/>
+                <a:moveTo>
+                  <a:pt x="2362200" y="0"/>
+                </a:moveTo>
+                <a:lnTo>
+                  <a:pt x="2476500" y="0"/>
+                </a:lnTo>
+                <a:lnTo>
+                  <a:pt x="2476500" y="114300"/>
+                </a:lnTo>
+                <a:lnTo>
+                  <a:pt x="2362200" y="114300"/>
+                </a:lnTo>
+                <a:close/>
+                <a:moveTo>
+                  <a:pt x="2705100" y="0"/>
+                </a:moveTo>
+                <a:lnTo>
+                  <a:pt x="2819400" y="0"/>
+                </a:lnTo>
+                <a:lnTo>
+                  <a:pt x="2819400" y="114300"/>
+                </a:lnTo>
+                <a:lnTo>
+                  <a:pt x="2705100" y="114300"/>
+                </a:lnTo>
+                <a:close/>
+                <a:moveTo>
+                  <a:pt x="2857500" y="0"/>
+                </a:moveTo>
+                <a:lnTo>
+                  <a:pt x="2971800" y="0"/>
+                </a:lnTo>
+                <a:lnTo>
+                  <a:pt x="2971800" y="114300"/>
+                </a:lnTo>
+                <a:lnTo>
+                  <a:pt x="2857500" y="114300"/>
+                </a:lnTo>
+                <a:close/>
+                <a:moveTo>
+                  <a:pt x="3009900" y="0"/>
+                </a:moveTo>
+                <a:lnTo>
+                  <a:pt x="3124200" y="0"/>
+                </a:lnTo>
+                <a:lnTo>
+                  <a:pt x="3124200" y="114300"/>
+                </a:lnTo>
+                <a:lnTo>
+                  <a:pt x="3009900" y="114300"/>
+                </a:lnTo>
+                <a:close/>
+                <a:moveTo>
+                  <a:pt x="3162300" y="0"/>
+                </a:moveTo>
+                <a:lnTo>
+                  <a:pt x="3276600" y="0"/>
+                </a:lnTo>
+                <a:lnTo>
+                  <a:pt x="3276600" y="114300"/>
+                </a:lnTo>
+                <a:lnTo>
+                  <a:pt x="3162300" y="114300"/>
+                </a:lnTo>
+                <a:close/>
+                <a:moveTo>
+                  <a:pt x="3505200" y="0"/>
+                </a:moveTo>
+                <a:lnTo>
+                  <a:pt x="3619500" y="0"/>
+                </a:lnTo>
+                <a:lnTo>
+                  <a:pt x="3619500" y="114300"/>
+                </a:lnTo>
+                <a:lnTo>
+                  <a:pt x="3505200" y="114300"/>
+                </a:lnTo>
+                <a:close/>
+                <a:moveTo>
+                  <a:pt x="3657600" y="0"/>
+                </a:moveTo>
+                <a:lnTo>
+                  <a:pt x="3771900" y="0"/>
+                </a:lnTo>
+                <a:lnTo>
+                  <a:pt x="3771900" y="114300"/>
+                </a:lnTo>
+                <a:lnTo>
+                  <a:pt x="3657600" y="114300"/>
+                </a:lnTo>
+                <a:close/>
+                <a:moveTo>
+                  <a:pt x="3810000" y="0"/>
+                </a:moveTo>
+                <a:lnTo>
+                  <a:pt x="3924300" y="0"/>
+                </a:lnTo>
+                <a:lnTo>
+                  <a:pt x="3924300" y="114300"/>
+                </a:lnTo>
+                <a:lnTo>
+                  <a:pt x="3810000" y="114300"/>
+                </a:lnTo>
+                <a:close/>
+                <a:moveTo>
+                  <a:pt x="3962400" y="0"/>
+                </a:moveTo>
+                <a:lnTo>
+                  <a:pt x="4076700" y="0"/>
+                </a:lnTo>
+                <a:lnTo>
+                  <a:pt x="4076700" y="114300"/>
+                </a:lnTo>
+                <a:lnTo>
+                  <a:pt x="3962400" y="114300"/>
+                </a:lnTo>
+                <a:close/>
+                <a:moveTo>
+                  <a:pt x="4114800" y="0"/>
+                </a:moveTo>
+                <a:lnTo>
+                  <a:pt x="4229100" y="0"/>
+                </a:lnTo>
+                <a:lnTo>
+                  <a:pt x="4229100" y="114300"/>
+                </a:lnTo>
+                <a:lnTo>
+                  <a:pt x="4114800" y="114300"/>
+                </a:lnTo>
+                <a:close/>
+                <a:moveTo>
+                  <a:pt x="4457700" y="0"/>
+                </a:moveTo>
+                <a:lnTo>
+                  <a:pt x="4572000" y="0"/>
+                </a:lnTo>
+                <a:lnTo>
+                  <a:pt x="4572000" y="114300"/>
+                </a:lnTo>
+                <a:lnTo>
+                  <a:pt x="4457700" y="114300"/>
+                </a:lnTo>
+                <a:close/>
+                <a:moveTo>
+                  <a:pt x="4610100" y="0"/>
+                </a:moveTo>
+                <a:lnTo>
+                  <a:pt x="4724400" y="0"/>
+                </a:lnTo>
+                <a:lnTo>
+                  <a:pt x="4724400" y="114300"/>
+                </a:lnTo>
+                <a:lnTo>
+                  <a:pt x="4610100" y="114300"/>
+                </a:lnTo>
+                <a:close/>
+                <a:moveTo>
+                  <a:pt x="4762500" y="0"/>
+                </a:moveTo>
+                <a:lnTo>
+                  <a:pt x="4876800" y="0"/>
+                </a:lnTo>
+                <a:lnTo>
+                  <a:pt x="4876800" y="114300"/>
+                </a:lnTo>
+                <a:lnTo>
+                  <a:pt x="4762500" y="114300"/>
+                </a:lnTo>
+                <a:close/>
+                <a:moveTo>
+                  <a:pt x="4914900" y="0"/>
+                </a:moveTo>
+                <a:lnTo>
+                  <a:pt x="5029200" y="0"/>
+                </a:lnTo>
+                <a:lnTo>
+                  <a:pt x="5029200" y="114300"/>
+                </a:lnTo>
+                <a:lnTo>
+                  <a:pt x="4914900" y="114300"/>
+                </a:lnTo>
+                <a:close/>
+                <a:moveTo>
+                  <a:pt x="5257800" y="0"/>
+                </a:moveTo>
+                <a:lnTo>
+                  <a:pt x="5372100" y="0"/>
+                </a:lnTo>
+                <a:lnTo>
+                  <a:pt x="5372100" y="114300"/>
+                </a:lnTo>
+                <a:lnTo>
+                  <a:pt x="5257800" y="114300"/>
+                </a:lnTo>
+                <a:close/>
+                <a:moveTo>
+                  <a:pt x="5410200" y="0"/>
+                </a:moveTo>
+                <a:lnTo>
+                  <a:pt x="5524500" y="0"/>
+                </a:lnTo>
+                <a:lnTo>
+                  <a:pt x="5524500" y="114300"/>
+                </a:lnTo>
+                <a:lnTo>
+                  <a:pt x="5410200" y="114300"/>
+                </a:lnTo>
+                <a:close/>
+                <a:moveTo>
+                  <a:pt x="5562600" y="0"/>
+                </a:moveTo>
+                <a:lnTo>
+                  <a:pt x="5676900" y="0"/>
+                </a:lnTo>
+                <a:lnTo>
+                  <a:pt x="5676900" y="114300"/>
+                </a:lnTo>
+                <a:lnTo>
+                  <a:pt x="5562600" y="114300"/>
+                </a:lnTo>
+                <a:close/>
+                <a:moveTo>
+                  <a:pt x="5715000" y="0"/>
+                </a:moveTo>
+                <a:lnTo>
+                  <a:pt x="5829300" y="0"/>
+                </a:lnTo>
+                <a:lnTo>
+                  <a:pt x="5829300" y="114300"/>
+                </a:lnTo>
+                <a:lnTo>
+                  <a:pt x="5715000" y="114300"/>
+                </a:lnTo>
+                <a:close/>
+                <a:moveTo>
+                  <a:pt x="5867400" y="0"/>
+                </a:moveTo>
+                <a:lnTo>
+                  <a:pt x="5981700" y="0"/>
+                </a:lnTo>
+                <a:lnTo>
+                  <a:pt x="5981700" y="114300"/>
+                </a:lnTo>
+                <a:lnTo>
+                  <a:pt x="5867400" y="114300"/>
+                </a:lnTo>
+                <a:close/>
+                <a:moveTo>
+                  <a:pt x="6210300" y="0"/>
+                </a:moveTo>
+                <a:lnTo>
+                  <a:pt x="6324600" y="0"/>
+                </a:lnTo>
+                <a:lnTo>
+                  <a:pt x="6324600" y="114300"/>
+                </a:lnTo>
+                <a:lnTo>
+                  <a:pt x="6210300" y="114300"/>
+                </a:lnTo>
+                <a:close/>
+                <a:moveTo>
+                  <a:pt x="6362700" y="0"/>
+                </a:moveTo>
+                <a:lnTo>
+                  <a:pt x="6477000" y="0"/>
+                </a:lnTo>
+                <a:lnTo>
+                  <a:pt x="6477000" y="114300"/>
+                </a:lnTo>
+                <a:lnTo>
+                  <a:pt x="6362700" y="114300"/>
+                </a:lnTo>
+                <a:close/>
+                <a:moveTo>
+                  <a:pt x="6515100" y="0"/>
+                </a:moveTo>
+                <a:lnTo>
+                  <a:pt x="6629400" y="0"/>
+                </a:lnTo>
+                <a:lnTo>
+                  <a:pt x="6629400" y="114300"/>
+                </a:lnTo>
+                <a:lnTo>
+                  <a:pt x="6515100" y="114300"/>
+                </a:lnTo>
+                <a:close/>
+                <a:moveTo>
+                  <a:pt x="6667500" y="0"/>
+                </a:moveTo>
+                <a:lnTo>
+                  <a:pt x="6781800" y="0"/>
+                </a:lnTo>
+                <a:lnTo>
+                  <a:pt x="6781800" y="114300"/>
+                </a:lnTo>
+                <a:lnTo>
+                  <a:pt x="6667500" y="114300"/>
+                </a:lnTo>
+                <a:close/>
+                <a:moveTo>
+                  <a:pt x="7010400" y="0"/>
+                </a:moveTo>
+                <a:lnTo>
+                  <a:pt x="7124700" y="0"/>
+                </a:lnTo>
+                <a:lnTo>
+                  <a:pt x="7124700" y="114300"/>
+                </a:lnTo>
+                <a:lnTo>
+                  <a:pt x="7010400" y="114300"/>
+                </a:lnTo>
+                <a:close/>
+                <a:moveTo>
+                  <a:pt x="7162800" y="0"/>
+                </a:moveTo>
+                <a:lnTo>
+                  <a:pt x="7277100" y="0"/>
+                </a:lnTo>
+                <a:lnTo>
+                  <a:pt x="7277100" y="114300"/>
+                </a:lnTo>
+                <a:lnTo>
+                  <a:pt x="7162800" y="114300"/>
+                </a:lnTo>
+                <a:close/>
+                <a:moveTo>
+                  <a:pt x="7315200" y="0"/>
+                </a:moveTo>
+                <a:lnTo>
+                  <a:pt x="7429500" y="0"/>
+                </a:lnTo>
+                <a:lnTo>
+                  <a:pt x="7429500" y="114300"/>
+                </a:lnTo>
+                <a:lnTo>
+                  <a:pt x="7315200" y="114300"/>
+                </a:lnTo>
+                <a:close/>
+                <a:moveTo>
+                  <a:pt x="7467600" y="0"/>
+                </a:moveTo>
+                <a:lnTo>
+                  <a:pt x="7581900" y="0"/>
+                </a:lnTo>
+                <a:lnTo>
+                  <a:pt x="7581900" y="114300"/>
+                </a:lnTo>
+                <a:lnTo>
+                  <a:pt x="7467600" y="114300"/>
+                </a:lnTo>
+                <a:close/>
+                <a:moveTo>
+                  <a:pt x="7620000" y="0"/>
+                </a:moveTo>
+                <a:lnTo>
+                  <a:pt x="7734300" y="0"/>
+                </a:lnTo>
+                <a:lnTo>
+                  <a:pt x="7734300" y="114300"/>
+                </a:lnTo>
+                <a:lnTo>
+                  <a:pt x="7620000" y="114300"/>
+                </a:lnTo>
+                <a:close/>
+                <a:moveTo>
+                  <a:pt x="7962900" y="0"/>
+                </a:moveTo>
+                <a:lnTo>
+                  <a:pt x="8077200" y="0"/>
+                </a:lnTo>
+                <a:lnTo>
+                  <a:pt x="8077200" y="114300"/>
+                </a:lnTo>
+                <a:lnTo>
+                  <a:pt x="7962900" y="114300"/>
+                </a:lnTo>
+                <a:close/>
+                <a:moveTo>
+                  <a:pt x="8115300" y="0"/>
+                </a:moveTo>
+                <a:lnTo>
+                  <a:pt x="8229600" y="0"/>
+                </a:lnTo>
+                <a:lnTo>
+                  <a:pt x="8229600" y="114300"/>
+                </a:lnTo>
+                <a:lnTo>
+                  <a:pt x="8115300" y="114300"/>
+                </a:lnTo>
+                <a:close/>
+                <a:moveTo>
+                  <a:pt x="8267700" y="0"/>
+                </a:moveTo>
+                <a:lnTo>
+                  <a:pt x="8382000" y="0"/>
+                </a:lnTo>
+                <a:lnTo>
+                  <a:pt x="8382000" y="114300"/>
+                </a:lnTo>
+                <a:lnTo>
+                  <a:pt x="8267700" y="114300"/>
+                </a:lnTo>
+                <a:close/>
+                <a:moveTo>
+                  <a:pt x="8420100" y="0"/>
+                </a:moveTo>
+                <a:lnTo>
+                  <a:pt x="8534400" y="0"/>
+                </a:lnTo>
+                <a:lnTo>
+                  <a:pt x="8534400" y="114300"/>
+                </a:lnTo>
+                <a:lnTo>
+                  <a:pt x="8420100" y="114300"/>
+                </a:lnTo>
+                <a:close/>
+                <a:moveTo>
+                  <a:pt x="8763000" y="0"/>
+                </a:moveTo>
+                <a:lnTo>
+                  <a:pt x="8877300" y="0"/>
+                </a:lnTo>
+                <a:lnTo>
+                  <a:pt x="8877300" y="114300"/>
+                </a:lnTo>
+                <a:lnTo>
+                  <a:pt x="8763000" y="114300"/>
+                </a:lnTo>
+                <a:close/>
+                <a:moveTo>
+                  <a:pt x="8915400" y="0"/>
+                </a:moveTo>
+                <a:lnTo>
+                  <a:pt x="9029700" y="0"/>
+                </a:lnTo>
+                <a:lnTo>
+                  <a:pt x="9029700" y="114300"/>
+                </a:lnTo>
+                <a:lnTo>
+                  <a:pt x="8915400" y="114300"/>
+                </a:lnTo>
+                <a:close/>
+                <a:moveTo>
+                  <a:pt x="9067800" y="0"/>
+                </a:moveTo>
+                <a:lnTo>
+                  <a:pt x="9182100" y="0"/>
+                </a:lnTo>
+                <a:lnTo>
+                  <a:pt x="9182100" y="114300"/>
+                </a:lnTo>
+                <a:lnTo>
+                  <a:pt x="9067800" y="114300"/>
+                </a:lnTo>
+                <a:close/>
+                <a:moveTo>
+                  <a:pt x="9220200" y="0"/>
+                </a:moveTo>
+                <a:lnTo>
+                  <a:pt x="9334500" y="0"/>
+                </a:lnTo>
+                <a:lnTo>
+                  <a:pt x="9334500" y="114300"/>
+                </a:lnTo>
+                <a:lnTo>
+                  <a:pt x="9220200" y="114300"/>
+                </a:lnTo>
+                <a:close/>
+                <a:moveTo>
+                  <a:pt x="9372600" y="0"/>
+                </a:moveTo>
+                <a:lnTo>
+                  <a:pt x="9486900" y="0"/>
+                </a:lnTo>
+                <a:lnTo>
+                  <a:pt x="9486900" y="114300"/>
+                </a:lnTo>
+                <a:lnTo>
+                  <a:pt x="9372600" y="114300"/>
+                </a:lnTo>
+                <a:close/>
+                <a:moveTo>
+                  <a:pt x="9715500" y="0"/>
+                </a:moveTo>
+                <a:lnTo>
+                  <a:pt x="9829800" y="0"/>
+                </a:lnTo>
+                <a:lnTo>
+                  <a:pt x="9829800" y="114300"/>
+                </a:lnTo>
+                <a:lnTo>
+                  <a:pt x="9715500" y="114300"/>
+                </a:lnTo>
+                <a:close/>
+                <a:moveTo>
+                  <a:pt x="9867900" y="0"/>
+                </a:moveTo>
+                <a:lnTo>
+                  <a:pt x="9982200" y="0"/>
+                </a:lnTo>
+                <a:lnTo>
+                  <a:pt x="9982200" y="114300"/>
+                </a:lnTo>
+                <a:lnTo>
+                  <a:pt x="9867900" y="114300"/>
+                </a:lnTo>
+                <a:close/>
+                <a:moveTo>
+                  <a:pt x="10020300" y="0"/>
+                </a:moveTo>
+                <a:lnTo>
+                  <a:pt x="10134600" y="0"/>
+                </a:lnTo>
+                <a:lnTo>
+                  <a:pt x="10134600" y="114300"/>
+                </a:lnTo>
+                <a:lnTo>
+                  <a:pt x="10020300" y="114300"/>
+                </a:lnTo>
+                <a:close/>
+                <a:moveTo>
+                  <a:pt x="10172700" y="0"/>
+                </a:moveTo>
+                <a:lnTo>
+                  <a:pt x="10287000" y="0"/>
+                </a:lnTo>
+                <a:lnTo>
+                  <a:pt x="10287000" y="114300"/>
+                </a:lnTo>
+                <a:lnTo>
+                  <a:pt x="10172700" y="114300"/>
+                </a:lnTo>
+                <a:close/>
+                <a:moveTo>
+                  <a:pt x="10515600" y="0"/>
+                </a:moveTo>
+                <a:lnTo>
+                  <a:pt x="10629900" y="0"/>
+                </a:lnTo>
+                <a:lnTo>
+                  <a:pt x="10629900" y="114300"/>
+                </a:lnTo>
+                <a:lnTo>
+                  <a:pt x="10515600" y="114300"/>
+                </a:lnTo>
+                <a:close/>
+                <a:moveTo>
+                  <a:pt x="10668000" y="0"/>
+                </a:moveTo>
+                <a:lnTo>
+                  <a:pt x="10782300" y="0"/>
+                </a:lnTo>
+                <a:lnTo>
+                  <a:pt x="10782300" y="114300"/>
+                </a:lnTo>
+                <a:lnTo>
+                  <a:pt x="10668000" y="114300"/>
+                </a:lnTo>
+                <a:close/>
+                <a:moveTo>
+                  <a:pt x="10820400" y="0"/>
+                </a:moveTo>
+                <a:lnTo>
+                  <a:pt x="10934700" y="0"/>
+                </a:lnTo>
+                <a:lnTo>
+                  <a:pt x="10934700" y="114300"/>
+                </a:lnTo>
+                <a:lnTo>
+                  <a:pt x="10820400" y="114300"/>
+                </a:lnTo>
+                <a:close/>
+                <a:moveTo>
+                  <a:pt x="10972800" y="0"/>
+                </a:moveTo>
+                <a:lnTo>
+                  <a:pt x="11087100" y="0"/>
+                </a:lnTo>
+                <a:lnTo>
+                  <a:pt x="11087100" y="114300"/>
+                </a:lnTo>
+                <a:lnTo>
+                  <a:pt x="10972800" y="114300"/>
+                </a:lnTo>
+                <a:close/>
+                <a:moveTo>
+                  <a:pt x="11125200" y="0"/>
+                </a:moveTo>
+                <a:lnTo>
+                  <a:pt x="11239500" y="0"/>
+                </a:lnTo>
+                <a:lnTo>
+                  <a:pt x="11239500" y="114300"/>
+                </a:lnTo>
+                <a:lnTo>
+                  <a:pt x="11125200" y="114300"/>
+                </a:lnTo>
+                <a:close/>
+                <a:moveTo>
+                  <a:pt x="11468100" y="0"/>
+                </a:moveTo>
+                <a:lnTo>
+                  <a:pt x="11582400" y="0"/>
+                </a:lnTo>
+                <a:lnTo>
+                  <a:pt x="11582400" y="114300"/>
+                </a:lnTo>
+                <a:lnTo>
+                  <a:pt x="11468100" y="114300"/>
+                </a:lnTo>
+                <a:close/>
+                <a:moveTo>
+                  <a:pt x="11620500" y="0"/>
+                </a:moveTo>
+                <a:lnTo>
+                  <a:pt x="11734800" y="0"/>
+                </a:lnTo>
+                <a:lnTo>
+                  <a:pt x="11734800" y="114300"/>
+                </a:lnTo>
+                <a:lnTo>
+                  <a:pt x="11620500" y="114300"/>
+                </a:lnTo>
+                <a:close/>
+                <a:moveTo>
+                  <a:pt x="11772900" y="0"/>
+                </a:moveTo>
+                <a:lnTo>
+                  <a:pt x="11887200" y="0"/>
+                </a:lnTo>
+                <a:lnTo>
+                  <a:pt x="11887200" y="114300"/>
+                </a:lnTo>
+                <a:lnTo>
+                  <a:pt x="11772900" y="114300"/>
+                </a:lnTo>
+                <a:close/>
+              </a:path>
+            </a:pathLst>
+          </a:custGeom>
+          <a:solidFill>
+            <a:srgbClr val="FFFFFF"/>
+          </a:solidFill>
+          <a:ln/>
+        </p:spPr>
+      </p:sp>
+      <p:sp>
+        <p:nvSpPr>
+          <p:cNvPr id="4" name=""/>
+          <p:cNvSpPr/>
+          <p:nvPr/>
+        </p:nvSpPr>
+        <p:spPr>
+          <a:xfrm>
+            <a:off x="10439400" y="342900"/>
+            <a:ext cx="1447800" cy="1447800"/>
+          </a:xfrm>
+          <a:custGeom>
+            <a:avLst/>
+            <a:gdLst/>
+            <a:ahLst/>
+            <a:cxnLst/>
+            <a:rect l="l" t="t" r="r" b="b"/>
+            <a:pathLst>
+              <a:path w="1447800" h="1447800">
+                <a:moveTo>
+                  <a:pt x="1447800" y="723900"/>
                 </a:moveTo>
                 <a:cubicBezTo>
-                  <a:pt x="2286000" y="1774508"/>
-                  <a:pt x="1774508" y="2286000"/>
-                  <a:pt x="1143000" y="2286000"/>
+                  <a:pt x="1447800" y="1123950"/>
+                  <a:pt x="1123950" y="1447800"/>
+                  <a:pt x="723900" y="1447800"/>
                 </a:cubicBezTo>
                 <a:cubicBezTo>
-                  <a:pt x="511492" y="2286000"/>
-                  <a:pt x="0" y="1774508"/>
-                  <a:pt x="0" y="1143000"/>
+                  <a:pt x="323850" y="1447800"/>
+                  <a:pt x="0" y="1123950"/>
+                  <a:pt x="0" y="723900"/>
                 </a:cubicBezTo>
                 <a:cubicBezTo>
-                  <a:pt x="0" y="511492"/>
-                  <a:pt x="511492" y="0"/>
-                  <a:pt x="1143000" y="0"/>
+                  <a:pt x="0" y="323850"/>
+                  <a:pt x="323850" y="0"/>
+                  <a:pt x="723900" y="0"/>
                 </a:cubicBezTo>
                 <a:cubicBezTo>
-                  <a:pt x="1774508" y="0"/>
-                  <a:pt x="2286000" y="511492"/>
-                  <a:pt x="2286000" y="1143000"/>
+                  <a:pt x="1123950" y="0"/>
+                  <a:pt x="1447800" y="323850"/>
+                  <a:pt x="1447800" y="723900"/>
                 </a:cubicBezTo>
                 <a:close/>
               </a:path>
             </a:pathLst>
           </a:custGeom>
           <a:solidFill>
-            <a:srgbClr val="A9D3F3"/>
-          </a:solidFill>
-          <a:ln/>
-        </p:spPr>
-      </p:sp>
-      <p:sp>
-        <p:nvSpPr>
-          <p:cNvPr id="3" name=""/>
-          <p:cNvSpPr/>
-          <p:nvPr/>
-        </p:nvSpPr>
-        <p:spPr>
-          <a:xfrm>
-            <a:off x="9144000" y="4191000"/>
-            <a:ext cx="1809750" cy="1809750"/>
+            <a:srgbClr val="FFF0B8"/>
+          </a:solidFill>
+          <a:ln/>
+        </p:spPr>
+      </p:sp>
+      <p:sp>
+        <p:nvSpPr>
+          <p:cNvPr id="5" name=""/>
+          <p:cNvSpPr/>
+          <p:nvPr/>
+        </p:nvSpPr>
+        <p:spPr>
+          <a:xfrm>
+            <a:off x="10668000" y="571500"/>
+            <a:ext cx="990600" cy="990600"/>
           </a:xfrm>
           <a:custGeom>
             <a:avLst/>
@@ -550,62 +1425,50 @@
             <a:cxnLst/>
             <a:rect l="l" t="t" r="r" b="b"/>
             <a:pathLst>
-              <a:path w="1809750" h="1809750">
+              <a:path w="990600" h="990600">
                 <a:moveTo>
-                  <a:pt x="457200" y="0"/>
+                  <a:pt x="990600" y="495300"/>
                 </a:moveTo>
-                <a:lnTo>
-                  <a:pt x="1352550" y="0"/>
-                </a:lnTo>
                 <a:cubicBezTo>
-                  <a:pt x="1604963" y="0"/>
-                  <a:pt x="1809750" y="204787"/>
-                  <a:pt x="1809750" y="457200"/>
+                  <a:pt x="990600" y="768667"/>
+                  <a:pt x="768668" y="990600"/>
+                  <a:pt x="495300" y="990600"/>
                 </a:cubicBezTo>
-                <a:lnTo>
-                  <a:pt x="1809750" y="1352550"/>
-                </a:lnTo>
                 <a:cubicBezTo>
-                  <a:pt x="1809750" y="1604963"/>
-                  <a:pt x="1604963" y="1809750"/>
-                  <a:pt x="1352550" y="1809750"/>
+                  <a:pt x="221932" y="990600"/>
+                  <a:pt x="0" y="768667"/>
+                  <a:pt x="0" y="495300"/>
                 </a:cubicBezTo>
-                <a:lnTo>
-                  <a:pt x="457200" y="1809750"/>
-                </a:lnTo>
                 <a:cubicBezTo>
-                  <a:pt x="204787" y="1809750"/>
-                  <a:pt x="0" y="1604963"/>
-                  <a:pt x="0" y="1352550"/>
+                  <a:pt x="0" y="221932"/>
+                  <a:pt x="221932" y="0"/>
+                  <a:pt x="495300" y="0"/>
                 </a:cubicBezTo>
-                <a:lnTo>
-                  <a:pt x="0" y="457200"/>
-                </a:lnTo>
                 <a:cubicBezTo>
-                  <a:pt x="0" y="204787"/>
-                  <a:pt x="204787" y="0"/>
-                  <a:pt x="457200" y="0"/>
+                  <a:pt x="768668" y="0"/>
+                  <a:pt x="990600" y="221932"/>
+                  <a:pt x="990600" y="495300"/>
                 </a:cubicBezTo>
                 <a:close/>
               </a:path>
             </a:pathLst>
           </a:custGeom>
           <a:solidFill>
-            <a:srgbClr val="FFD3DD"/>
-          </a:solidFill>
-          <a:ln/>
-        </p:spPr>
-      </p:sp>
-      <p:sp>
-        <p:nvSpPr>
-          <p:cNvPr id="4" name=""/>
-          <p:cNvSpPr/>
-          <p:nvPr/>
-        </p:nvSpPr>
-        <p:spPr>
-          <a:xfrm>
-            <a:off x="10039350" y="895350"/>
-            <a:ext cx="1066800" cy="1066800"/>
+            <a:srgbClr val="FFD24A"/>
+          </a:solidFill>
+          <a:ln/>
+        </p:spPr>
+      </p:sp>
+      <p:sp>
+        <p:nvSpPr>
+          <p:cNvPr id="6" name=""/>
+          <p:cNvSpPr/>
+          <p:nvPr/>
+        </p:nvSpPr>
+        <p:spPr>
+          <a:xfrm>
+            <a:off x="876300" y="742950"/>
+            <a:ext cx="1162050" cy="723900"/>
           </a:xfrm>
           <a:custGeom>
             <a:avLst/>
@@ -614,50 +1477,98 @@
             <a:cxnLst/>
             <a:rect l="l" t="t" r="r" b="b"/>
             <a:pathLst>
-              <a:path w="1066800" h="1066800">
+              <a:path w="1162050" h="723900">
                 <a:moveTo>
-                  <a:pt x="1066800" y="533400"/>
+                  <a:pt x="495300" y="476250"/>
                 </a:moveTo>
                 <a:cubicBezTo>
-                  <a:pt x="1066800" y="827723"/>
-                  <a:pt x="827723" y="1066800"/>
-                  <a:pt x="533400" y="1066800"/>
+                  <a:pt x="495300" y="613410"/>
+                  <a:pt x="384810" y="723900"/>
+                  <a:pt x="247650" y="723900"/>
                 </a:cubicBezTo>
                 <a:cubicBezTo>
-                  <a:pt x="239077" y="1066800"/>
-                  <a:pt x="0" y="827723"/>
-                  <a:pt x="0" y="533400"/>
+                  <a:pt x="110490" y="723900"/>
+                  <a:pt x="0" y="613410"/>
+                  <a:pt x="0" y="476250"/>
                 </a:cubicBezTo>
                 <a:cubicBezTo>
-                  <a:pt x="0" y="239077"/>
-                  <a:pt x="239077" y="0"/>
-                  <a:pt x="533400" y="0"/>
+                  <a:pt x="0" y="339090"/>
+                  <a:pt x="110490" y="228600"/>
+                  <a:pt x="247650" y="228600"/>
                 </a:cubicBezTo>
                 <a:cubicBezTo>
-                  <a:pt x="827723" y="0"/>
-                  <a:pt x="1066800" y="239077"/>
-                  <a:pt x="1066800" y="533400"/>
+                  <a:pt x="384810" y="228600"/>
+                  <a:pt x="495300" y="339090"/>
+                  <a:pt x="495300" y="476250"/>
+                </a:cubicBezTo>
+                <a:close/>
+                <a:moveTo>
+                  <a:pt x="895350" y="323850"/>
+                </a:moveTo>
+                <a:cubicBezTo>
+                  <a:pt x="895350" y="502920"/>
+                  <a:pt x="750570" y="647700"/>
+                  <a:pt x="571500" y="647700"/>
+                </a:cubicBezTo>
+                <a:cubicBezTo>
+                  <a:pt x="392430" y="647700"/>
+                  <a:pt x="247650" y="502920"/>
+                  <a:pt x="247650" y="323850"/>
+                </a:cubicBezTo>
+                <a:cubicBezTo>
+                  <a:pt x="247650" y="144780"/>
+                  <a:pt x="392430" y="0"/>
+                  <a:pt x="571500" y="0"/>
+                </a:cubicBezTo>
+                <a:cubicBezTo>
+                  <a:pt x="750570" y="0"/>
+                  <a:pt x="895350" y="144780"/>
+                  <a:pt x="895350" y="323850"/>
+                </a:cubicBezTo>
+                <a:close/>
+                <a:moveTo>
+                  <a:pt x="1162050" y="495300"/>
+                </a:moveTo>
+                <a:cubicBezTo>
+                  <a:pt x="1162050" y="621983"/>
+                  <a:pt x="1060133" y="723900"/>
+                  <a:pt x="933450" y="723900"/>
+                </a:cubicBezTo>
+                <a:cubicBezTo>
+                  <a:pt x="806767" y="723900"/>
+                  <a:pt x="704850" y="621983"/>
+                  <a:pt x="704850" y="495300"/>
+                </a:cubicBezTo>
+                <a:cubicBezTo>
+                  <a:pt x="704850" y="368618"/>
+                  <a:pt x="806767" y="266700"/>
+                  <a:pt x="933450" y="266700"/>
+                </a:cubicBezTo>
+                <a:cubicBezTo>
+                  <a:pt x="1060133" y="266700"/>
+                  <a:pt x="1162050" y="368618"/>
+                  <a:pt x="1162050" y="495300"/>
                 </a:cubicBezTo>
                 <a:close/>
               </a:path>
             </a:pathLst>
           </a:custGeom>
           <a:solidFill>
-            <a:srgbClr val="FFD966"/>
-          </a:solidFill>
-          <a:ln/>
-        </p:spPr>
-      </p:sp>
-      <p:sp>
-        <p:nvSpPr>
-          <p:cNvPr id="5" name=""/>
-          <p:cNvSpPr/>
-          <p:nvPr/>
-        </p:nvSpPr>
-        <p:spPr>
-          <a:xfrm>
-            <a:off x="1247775" y="4772025"/>
-            <a:ext cx="838200" cy="838200"/>
+            <a:srgbClr val="FFFFFF"/>
+          </a:solidFill>
+          <a:ln/>
+        </p:spPr>
+      </p:sp>
+      <p:sp>
+        <p:nvSpPr>
+          <p:cNvPr id="7" name=""/>
+          <p:cNvSpPr/>
+          <p:nvPr/>
+        </p:nvSpPr>
+        <p:spPr>
+          <a:xfrm>
+            <a:off x="8686800" y="552450"/>
+            <a:ext cx="838200" cy="495300"/>
           </a:xfrm>
           <a:custGeom>
             <a:avLst/>
@@ -666,50 +1577,98 @@
             <a:cxnLst/>
             <a:rect l="l" t="t" r="r" b="b"/>
             <a:pathLst>
-              <a:path w="838200" h="838200">
+              <a:path w="838200" h="495300">
                 <a:moveTo>
-                  <a:pt x="838200" y="419100"/>
+                  <a:pt x="342900" y="323850"/>
                 </a:moveTo>
                 <a:cubicBezTo>
-                  <a:pt x="838200" y="650557"/>
-                  <a:pt x="650558" y="838200"/>
-                  <a:pt x="419100" y="838200"/>
+                  <a:pt x="342900" y="418148"/>
+                  <a:pt x="265747" y="495300"/>
+                  <a:pt x="171450" y="495300"/>
                 </a:cubicBezTo>
                 <a:cubicBezTo>
-                  <a:pt x="187642" y="838200"/>
-                  <a:pt x="0" y="650557"/>
-                  <a:pt x="0" y="419100"/>
+                  <a:pt x="77153" y="495300"/>
+                  <a:pt x="0" y="418148"/>
+                  <a:pt x="0" y="323850"/>
                 </a:cubicBezTo>
                 <a:cubicBezTo>
-                  <a:pt x="0" y="187643"/>
-                  <a:pt x="187642" y="0"/>
+                  <a:pt x="0" y="229552"/>
+                  <a:pt x="77153" y="152400"/>
+                  <a:pt x="171450" y="152400"/>
+                </a:cubicBezTo>
+                <a:cubicBezTo>
+                  <a:pt x="265747" y="152400"/>
+                  <a:pt x="342900" y="229552"/>
+                  <a:pt x="342900" y="323850"/>
+                </a:cubicBezTo>
+                <a:close/>
+                <a:moveTo>
+                  <a:pt x="647700" y="228600"/>
+                </a:moveTo>
+                <a:cubicBezTo>
+                  <a:pt x="647700" y="355282"/>
+                  <a:pt x="545782" y="457200"/>
+                  <a:pt x="419100" y="457200"/>
+                </a:cubicBezTo>
+                <a:cubicBezTo>
+                  <a:pt x="292418" y="457200"/>
+                  <a:pt x="190500" y="355282"/>
+                  <a:pt x="190500" y="228600"/>
+                </a:cubicBezTo>
+                <a:cubicBezTo>
+                  <a:pt x="190500" y="101918"/>
+                  <a:pt x="292418" y="0"/>
                   <a:pt x="419100" y="0"/>
                 </a:cubicBezTo>
                 <a:cubicBezTo>
-                  <a:pt x="650558" y="0"/>
-                  <a:pt x="838200" y="187643"/>
-                  <a:pt x="838200" y="419100"/>
+                  <a:pt x="545782" y="0"/>
+                  <a:pt x="647700" y="101918"/>
+                  <a:pt x="647700" y="228600"/>
+                </a:cubicBezTo>
+                <a:close/>
+                <a:moveTo>
+                  <a:pt x="838200" y="342900"/>
+                </a:moveTo>
+                <a:cubicBezTo>
+                  <a:pt x="838200" y="426720"/>
+                  <a:pt x="769620" y="495300"/>
+                  <a:pt x="685800" y="495300"/>
+                </a:cubicBezTo>
+                <a:cubicBezTo>
+                  <a:pt x="601980" y="495300"/>
+                  <a:pt x="533400" y="426720"/>
+                  <a:pt x="533400" y="342900"/>
+                </a:cubicBezTo>
+                <a:cubicBezTo>
+                  <a:pt x="533400" y="259080"/>
+                  <a:pt x="601980" y="190500"/>
+                  <a:pt x="685800" y="190500"/>
+                </a:cubicBezTo>
+                <a:cubicBezTo>
+                  <a:pt x="769620" y="190500"/>
+                  <a:pt x="838200" y="259080"/>
+                  <a:pt x="838200" y="342900"/>
                 </a:cubicBezTo>
                 <a:close/>
               </a:path>
             </a:pathLst>
           </a:custGeom>
           <a:solidFill>
-            <a:srgbClr val="FF9C6E"/>
-          </a:solidFill>
-          <a:ln/>
-        </p:spPr>
-      </p:sp>
-      <p:sp>
-        <p:nvSpPr>
-          <p:cNvPr id="6" name=""/>
-          <p:cNvSpPr/>
-          <p:nvPr/>
-        </p:nvSpPr>
-        <p:spPr>
-          <a:xfrm>
-            <a:off x="771525" y="3295650"/>
-            <a:ext cx="266700" cy="266700"/>
+            <a:srgbClr val="FFFFFF"/>
+          </a:solidFill>
+          <a:ln/>
+        </p:spPr>
+      </p:sp>
+      <p:sp>
+        <p:nvSpPr>
+          <p:cNvPr id="8" name=""/>
+          <p:cNvSpPr/>
+          <p:nvPr/>
+        </p:nvSpPr>
+        <p:spPr>
+          <a:xfrm>
+            <a:off x="0" y="4629150"/>
+            <a:ext cx="12192000" cy="2228850"/>
           </a:xfrm>
           <a:custGeom>
             <a:avLst/>
@@ -718,50 +1677,255 @@
             <a:cxnLst/>
             <a:rect l="l" t="t" r="r" b="b"/>
             <a:pathLst>
-              <a:path w="266700" h="266700">
+              <a:path w="12192000" h="2228850">
                 <a:moveTo>
-                  <a:pt x="266700" y="133350"/>
+                  <a:pt x="0" y="133350"/>
                 </a:moveTo>
                 <a:cubicBezTo>
-                  <a:pt x="266700" y="206692"/>
-                  <a:pt x="206693" y="266700"/>
-                  <a:pt x="133350" y="266700"/>
+                  <a:pt x="1524000" y="0"/>
+                  <a:pt x="3048000" y="266700"/>
+                  <a:pt x="4572000" y="133350"/>
                 </a:cubicBezTo>
                 <a:cubicBezTo>
-                  <a:pt x="60007" y="266700"/>
-                  <a:pt x="0" y="206692"/>
-                  <a:pt x="0" y="133350"/>
+                  <a:pt x="6096000" y="0"/>
+                  <a:pt x="7620000" y="266700"/>
+                  <a:pt x="9144000" y="133350"/>
                 </a:cubicBezTo>
                 <a:cubicBezTo>
-                  <a:pt x="0" y="60008"/>
-                  <a:pt x="60007" y="0"/>
-                  <a:pt x="133350" y="0"/>
+                  <a:pt x="10668000" y="0"/>
+                  <a:pt x="11430000" y="266700"/>
+                  <a:pt x="12192000" y="133350"/>
+                </a:cubicBezTo>
+                <a:lnTo>
+                  <a:pt x="12192000" y="2228850"/>
+                </a:lnTo>
+                <a:lnTo>
+                  <a:pt x="0" y="2228850"/>
+                </a:lnTo>
+                <a:close/>
+              </a:path>
+            </a:pathLst>
+          </a:custGeom>
+          <a:solidFill>
+            <a:srgbClr val="86D9E6"/>
+          </a:solidFill>
+          <a:ln/>
+        </p:spPr>
+      </p:sp>
+      <p:sp>
+        <p:nvSpPr>
+          <p:cNvPr id="9" name=""/>
+          <p:cNvSpPr/>
+          <p:nvPr/>
+        </p:nvSpPr>
+        <p:spPr>
+          <a:xfrm>
+            <a:off x="0" y="5276850"/>
+            <a:ext cx="12192000" cy="1581150"/>
+          </a:xfrm>
+          <a:custGeom>
+            <a:avLst/>
+            <a:gdLst/>
+            <a:ahLst/>
+            <a:cxnLst/>
+            <a:rect l="l" t="t" r="r" b="b"/>
+            <a:pathLst>
+              <a:path w="12192000" h="1581150">
+                <a:moveTo>
+                  <a:pt x="0" y="114300"/>
+                </a:moveTo>
+                <a:cubicBezTo>
+                  <a:pt x="1524000" y="0"/>
+                  <a:pt x="3048000" y="228600"/>
+                  <a:pt x="4572000" y="114300"/>
                 </a:cubicBezTo>
                 <a:cubicBezTo>
-                  <a:pt x="206693" y="0"/>
-                  <a:pt x="266700" y="60008"/>
-                  <a:pt x="266700" y="133350"/>
+                  <a:pt x="6096000" y="0"/>
+                  <a:pt x="7620000" y="228600"/>
+                  <a:pt x="9144000" y="114300"/>
+                </a:cubicBezTo>
+                <a:cubicBezTo>
+                  <a:pt x="10668000" y="0"/>
+                  <a:pt x="11430000" y="228600"/>
+                  <a:pt x="12192000" y="114300"/>
+                </a:cubicBezTo>
+                <a:lnTo>
+                  <a:pt x="12192000" y="1581150"/>
+                </a:lnTo>
+                <a:lnTo>
+                  <a:pt x="0" y="1581150"/>
+                </a:lnTo>
+                <a:close/>
+              </a:path>
+            </a:pathLst>
+          </a:custGeom>
+          <a:solidFill>
+            <a:srgbClr val="2AB3CB"/>
+          </a:solidFill>
+          <a:ln/>
+        </p:spPr>
+      </p:sp>
+      <p:sp>
+        <p:nvSpPr>
+          <p:cNvPr id="10" name=""/>
+          <p:cNvSpPr/>
+          <p:nvPr/>
+        </p:nvSpPr>
+        <p:spPr>
+          <a:xfrm>
+            <a:off x="0" y="6019800"/>
+            <a:ext cx="12192000" cy="838200"/>
+          </a:xfrm>
+          <a:custGeom>
+            <a:avLst/>
+            <a:gdLst/>
+            <a:ahLst/>
+            <a:cxnLst/>
+            <a:rect l="l" t="t" r="r" b="b"/>
+            <a:pathLst>
+              <a:path w="12192000" h="838200">
+                <a:moveTo>
+                  <a:pt x="0" y="76200"/>
+                </a:moveTo>
+                <a:cubicBezTo>
+                  <a:pt x="1524000" y="0"/>
+                  <a:pt x="3048000" y="152400"/>
+                  <a:pt x="4572000" y="76200"/>
+                </a:cubicBezTo>
+                <a:cubicBezTo>
+                  <a:pt x="6096000" y="0"/>
+                  <a:pt x="7620000" y="152400"/>
+                  <a:pt x="9144000" y="76200"/>
+                </a:cubicBezTo>
+                <a:cubicBezTo>
+                  <a:pt x="10668000" y="0"/>
+                  <a:pt x="11430000" y="152400"/>
+                  <a:pt x="12192000" y="76200"/>
+                </a:cubicBezTo>
+                <a:lnTo>
+                  <a:pt x="12192000" y="838200"/>
+                </a:lnTo>
+                <a:lnTo>
+                  <a:pt x="0" y="838200"/>
+                </a:lnTo>
+                <a:close/>
+              </a:path>
+            </a:pathLst>
+          </a:custGeom>
+          <a:solidFill>
+            <a:srgbClr val="FFFFFF"/>
+          </a:solidFill>
+          <a:ln/>
+        </p:spPr>
+      </p:sp>
+      <p:sp>
+        <p:nvSpPr>
+          <p:cNvPr id="11" name=""/>
+          <p:cNvSpPr/>
+          <p:nvPr/>
+        </p:nvSpPr>
+        <p:spPr>
+          <a:xfrm>
+            <a:off x="0" y="6096000"/>
+            <a:ext cx="12192000" cy="762000"/>
+          </a:xfrm>
+          <a:custGeom>
+            <a:avLst/>
+            <a:gdLst/>
+            <a:ahLst/>
+            <a:cxnLst/>
+            <a:rect l="l" t="t" r="r" b="b"/>
+            <a:pathLst>
+              <a:path w="12192000" h="762000">
+                <a:moveTo>
+                  <a:pt x="0" y="76200"/>
+                </a:moveTo>
+                <a:cubicBezTo>
+                  <a:pt x="1524000" y="0"/>
+                  <a:pt x="3048000" y="152400"/>
+                  <a:pt x="4572000" y="76200"/>
+                </a:cubicBezTo>
+                <a:cubicBezTo>
+                  <a:pt x="6096000" y="0"/>
+                  <a:pt x="7620000" y="152400"/>
+                  <a:pt x="9144000" y="76200"/>
+                </a:cubicBezTo>
+                <a:cubicBezTo>
+                  <a:pt x="10668000" y="0"/>
+                  <a:pt x="11430000" y="152400"/>
+                  <a:pt x="12192000" y="76200"/>
+                </a:cubicBezTo>
+                <a:lnTo>
+                  <a:pt x="12192000" y="762000"/>
+                </a:lnTo>
+                <a:lnTo>
+                  <a:pt x="0" y="762000"/>
+                </a:lnTo>
+                <a:close/>
+              </a:path>
+            </a:pathLst>
+          </a:custGeom>
+          <a:solidFill>
+            <a:srgbClr val="FBE8C4"/>
+          </a:solidFill>
+          <a:ln/>
+        </p:spPr>
+      </p:sp>
+      <p:sp>
+        <p:nvSpPr>
+          <p:cNvPr id="12" name=""/>
+          <p:cNvSpPr/>
+          <p:nvPr/>
+        </p:nvSpPr>
+        <p:spPr>
+          <a:xfrm>
+            <a:off x="11125200" y="4038600"/>
+            <a:ext cx="609600" cy="2819400"/>
+          </a:xfrm>
+          <a:custGeom>
+            <a:avLst/>
+            <a:gdLst/>
+            <a:ahLst/>
+            <a:cxnLst/>
+            <a:rect l="l" t="t" r="r" b="b"/>
+            <a:pathLst>
+              <a:path w="609600" h="2819400">
+                <a:moveTo>
+                  <a:pt x="361950" y="2819400"/>
+                </a:moveTo>
+                <a:cubicBezTo>
+                  <a:pt x="266700" y="1771650"/>
+                  <a:pt x="171450" y="723900"/>
+                  <a:pt x="0" y="0"/>
+                </a:cubicBezTo>
+                <a:lnTo>
+                  <a:pt x="152400" y="19050"/>
+                </a:lnTo>
+                <a:cubicBezTo>
+                  <a:pt x="323850" y="723900"/>
+                  <a:pt x="514350" y="1771650"/>
+                  <a:pt x="609600" y="2819400"/>
                 </a:cubicBezTo>
                 <a:close/>
               </a:path>
             </a:pathLst>
           </a:custGeom>
           <a:solidFill>
-            <a:srgbClr val="FF9DB4"/>
-          </a:solidFill>
-          <a:ln/>
-        </p:spPr>
-      </p:sp>
-      <p:sp>
-        <p:nvSpPr>
-          <p:cNvPr id="7" name=""/>
-          <p:cNvSpPr/>
-          <p:nvPr/>
-        </p:nvSpPr>
-        <p:spPr>
-          <a:xfrm>
-            <a:off x="11268075" y="3505200"/>
-            <a:ext cx="228600" cy="228600"/>
+            <a:srgbClr val="A8743F"/>
+          </a:solidFill>
+          <a:ln/>
+        </p:spPr>
+      </p:sp>
+      <p:sp>
+        <p:nvSpPr>
+          <p:cNvPr id="13" name=""/>
+          <p:cNvSpPr/>
+          <p:nvPr/>
+        </p:nvSpPr>
+        <p:spPr>
+          <a:xfrm>
+            <a:off x="10248900" y="3590925"/>
+            <a:ext cx="952500" cy="533400"/>
           </a:xfrm>
           <a:custGeom>
             <a:avLst/>
@@ -770,50 +1934,40 @@
             <a:cxnLst/>
             <a:rect l="l" t="t" r="r" b="b"/>
             <a:pathLst>
-              <a:path w="228600" h="228600">
+              <a:path w="952500" h="533400">
                 <a:moveTo>
-                  <a:pt x="228600" y="114300"/>
+                  <a:pt x="948690" y="446722"/>
                 </a:moveTo>
                 <a:cubicBezTo>
-                  <a:pt x="228600" y="177165"/>
-                  <a:pt x="177165" y="228600"/>
-                  <a:pt x="114300" y="228600"/>
+                  <a:pt x="732472" y="155257"/>
+                  <a:pt x="305752" y="0"/>
+                  <a:pt x="0" y="100965"/>
                 </a:cubicBezTo>
                 <a:cubicBezTo>
-                  <a:pt x="51435" y="228600"/>
-                  <a:pt x="0" y="177165"/>
-                  <a:pt x="0" y="114300"/>
-                </a:cubicBezTo>
-                <a:cubicBezTo>
-                  <a:pt x="0" y="51435"/>
-                  <a:pt x="51435" y="0"/>
-                  <a:pt x="114300" y="0"/>
-                </a:cubicBezTo>
-                <a:cubicBezTo>
-                  <a:pt x="177165" y="0"/>
-                  <a:pt x="228600" y="51435"/>
-                  <a:pt x="228600" y="114300"/>
+                  <a:pt x="168592" y="375285"/>
+                  <a:pt x="595313" y="531495"/>
+                  <a:pt x="948690" y="446722"/>
                 </a:cubicBezTo>
                 <a:close/>
               </a:path>
             </a:pathLst>
           </a:custGeom>
           <a:solidFill>
-            <a:srgbClr val="7DBDEB"/>
-          </a:solidFill>
-          <a:ln/>
-        </p:spPr>
-      </p:sp>
-      <p:sp>
-        <p:nvSpPr>
-          <p:cNvPr id="8" name=""/>
-          <p:cNvSpPr/>
-          <p:nvPr/>
-        </p:nvSpPr>
-        <p:spPr>
-          <a:xfrm>
-            <a:off x="5619750" y="809625"/>
-            <a:ext cx="190500" cy="190500"/>
+            <a:srgbClr val="2E9E64"/>
+          </a:solidFill>
+          <a:ln/>
+        </p:spPr>
+      </p:sp>
+      <p:sp>
+        <p:nvSpPr>
+          <p:cNvPr id="14" name=""/>
+          <p:cNvSpPr/>
+          <p:nvPr/>
+        </p:nvSpPr>
+        <p:spPr>
+          <a:xfrm>
+            <a:off x="10487025" y="3324225"/>
+            <a:ext cx="714375" cy="714375"/>
           </a:xfrm>
           <a:custGeom>
             <a:avLst/>
@@ -822,49 +1976,1240 @@
             <a:cxnLst/>
             <a:rect l="l" t="t" r="r" b="b"/>
             <a:pathLst>
-              <a:path w="190500" h="190500">
+              <a:path w="714375" h="714375">
                 <a:moveTo>
-                  <a:pt x="190500" y="95250"/>
+                  <a:pt x="714375" y="714375"/>
                 </a:moveTo>
                 <a:cubicBezTo>
-                  <a:pt x="190500" y="147637"/>
-                  <a:pt x="147637" y="190500"/>
-                  <a:pt x="95250" y="190500"/>
+                  <a:pt x="641985" y="359092"/>
+                  <a:pt x="320040" y="37147"/>
+                  <a:pt x="0" y="0"/>
                 </a:cubicBezTo>
                 <a:cubicBezTo>
-                  <a:pt x="42863" y="190500"/>
-                  <a:pt x="0" y="147637"/>
-                  <a:pt x="0" y="95250"/>
-                </a:cubicBezTo>
-                <a:cubicBezTo>
-                  <a:pt x="0" y="42863"/>
-                  <a:pt x="42863" y="0"/>
-                  <a:pt x="95250" y="0"/>
-                </a:cubicBezTo>
-                <a:cubicBezTo>
-                  <a:pt x="147637" y="0"/>
-                  <a:pt x="190500" y="42863"/>
-                  <a:pt x="190500" y="95250"/>
+                  <a:pt x="37148" y="320040"/>
+                  <a:pt x="359093" y="641985"/>
+                  <a:pt x="714375" y="714375"/>
                 </a:cubicBezTo>
                 <a:close/>
               </a:path>
             </a:pathLst>
           </a:custGeom>
           <a:solidFill>
-            <a:srgbClr val="FFC94A"/>
-          </a:solidFill>
-          <a:ln/>
-        </p:spPr>
-      </p:sp>
-      <p:sp>
-        <p:nvSpPr>
-          <p:cNvPr id="9" name=""/>
-          <p:cNvSpPr/>
-          <p:nvPr/>
-        </p:nvSpPr>
-        <p:spPr>
-          <a:xfrm>
-            <a:off x="9448800" y="781050"/>
+            <a:srgbClr val="23824F"/>
+          </a:solidFill>
+          <a:ln/>
+        </p:spPr>
+      </p:sp>
+      <p:sp>
+        <p:nvSpPr>
+          <p:cNvPr id="15" name=""/>
+          <p:cNvSpPr/>
+          <p:nvPr/>
+        </p:nvSpPr>
+        <p:spPr>
+          <a:xfrm>
+            <a:off x="10810875" y="3067050"/>
+            <a:ext cx="504825" cy="971550"/>
+          </a:xfrm>
+          <a:custGeom>
+            <a:avLst/>
+            <a:gdLst/>
+            <a:ahLst/>
+            <a:cxnLst/>
+            <a:rect l="l" t="t" r="r" b="b"/>
+            <a:pathLst>
+              <a:path w="504825" h="971550">
+                <a:moveTo>
+                  <a:pt x="389573" y="975360"/>
+                </a:moveTo>
+                <a:cubicBezTo>
+                  <a:pt x="504825" y="630555"/>
+                  <a:pt x="386715" y="192405"/>
+                  <a:pt x="128588" y="0"/>
+                </a:cubicBezTo>
+                <a:cubicBezTo>
+                  <a:pt x="0" y="295275"/>
+                  <a:pt x="118110" y="734377"/>
+                  <a:pt x="389573" y="975360"/>
+                </a:cubicBezTo>
+                <a:close/>
+              </a:path>
+            </a:pathLst>
+          </a:custGeom>
+          <a:solidFill>
+            <a:srgbClr val="2E9E64"/>
+          </a:solidFill>
+          <a:ln/>
+        </p:spPr>
+      </p:sp>
+      <p:sp>
+        <p:nvSpPr>
+          <p:cNvPr id="16" name=""/>
+          <p:cNvSpPr/>
+          <p:nvPr/>
+        </p:nvSpPr>
+        <p:spPr>
+          <a:xfrm>
+            <a:off x="11115675" y="3086100"/>
+            <a:ext cx="533400" cy="952500"/>
+          </a:xfrm>
+          <a:custGeom>
+            <a:avLst/>
+            <a:gdLst/>
+            <a:ahLst/>
+            <a:cxnLst/>
+            <a:rect l="l" t="t" r="r" b="b"/>
+            <a:pathLst>
+              <a:path w="533400" h="952500">
+                <a:moveTo>
+                  <a:pt x="84773" y="948690"/>
+                </a:moveTo>
+                <a:cubicBezTo>
+                  <a:pt x="376238" y="732473"/>
+                  <a:pt x="531495" y="305753"/>
+                  <a:pt x="430530" y="0"/>
+                </a:cubicBezTo>
+                <a:cubicBezTo>
+                  <a:pt x="156210" y="168593"/>
+                  <a:pt x="0" y="595313"/>
+                  <a:pt x="84773" y="948690"/>
+                </a:cubicBezTo>
+                <a:close/>
+              </a:path>
+            </a:pathLst>
+          </a:custGeom>
+          <a:solidFill>
+            <a:srgbClr val="23824F"/>
+          </a:solidFill>
+          <a:ln/>
+        </p:spPr>
+      </p:sp>
+      <p:sp>
+        <p:nvSpPr>
+          <p:cNvPr id="17" name=""/>
+          <p:cNvSpPr/>
+          <p:nvPr/>
+        </p:nvSpPr>
+        <p:spPr>
+          <a:xfrm>
+            <a:off x="11201400" y="3390900"/>
+            <a:ext cx="771525" cy="647700"/>
+          </a:xfrm>
+          <a:custGeom>
+            <a:avLst/>
+            <a:gdLst/>
+            <a:ahLst/>
+            <a:cxnLst/>
+            <a:rect l="l" t="t" r="r" b="b"/>
+            <a:pathLst>
+              <a:path w="771525" h="647700">
+                <a:moveTo>
+                  <a:pt x="0" y="648653"/>
+                </a:moveTo>
+                <a:cubicBezTo>
+                  <a:pt x="360998" y="606743"/>
+                  <a:pt x="708660" y="315278"/>
+                  <a:pt x="773430" y="0"/>
+                </a:cubicBezTo>
+                <a:cubicBezTo>
+                  <a:pt x="451485" y="8573"/>
+                  <a:pt x="103823" y="300990"/>
+                  <a:pt x="0" y="648653"/>
+                </a:cubicBezTo>
+                <a:close/>
+              </a:path>
+            </a:pathLst>
+          </a:custGeom>
+          <a:solidFill>
+            <a:srgbClr val="2E9E64"/>
+          </a:solidFill>
+          <a:ln/>
+        </p:spPr>
+      </p:sp>
+      <p:sp>
+        <p:nvSpPr>
+          <p:cNvPr id="18" name=""/>
+          <p:cNvSpPr/>
+          <p:nvPr/>
+        </p:nvSpPr>
+        <p:spPr>
+          <a:xfrm>
+            <a:off x="11201400" y="3714750"/>
+            <a:ext cx="990600" cy="476250"/>
+          </a:xfrm>
+          <a:custGeom>
+            <a:avLst/>
+            <a:gdLst/>
+            <a:ahLst/>
+            <a:cxnLst/>
+            <a:rect l="l" t="t" r="r" b="b"/>
+            <a:pathLst>
+              <a:path w="990600" h="476250">
+                <a:moveTo>
+                  <a:pt x="0" y="328613"/>
+                </a:moveTo>
+                <a:cubicBezTo>
+                  <a:pt x="333375" y="473392"/>
+                  <a:pt x="780098" y="394335"/>
+                  <a:pt x="994410" y="153353"/>
+                </a:cubicBezTo>
+                <a:cubicBezTo>
+                  <a:pt x="710565" y="0"/>
+                  <a:pt x="263843" y="79058"/>
+                  <a:pt x="0" y="328613"/>
+                </a:cubicBezTo>
+                <a:close/>
+              </a:path>
+            </a:pathLst>
+          </a:custGeom>
+          <a:solidFill>
+            <a:srgbClr val="23824F"/>
+          </a:solidFill>
+          <a:ln/>
+        </p:spPr>
+      </p:sp>
+      <p:sp>
+        <p:nvSpPr>
+          <p:cNvPr id="19" name=""/>
+          <p:cNvSpPr/>
+          <p:nvPr/>
+        </p:nvSpPr>
+        <p:spPr>
+          <a:xfrm>
+            <a:off x="11201400" y="3952875"/>
+            <a:ext cx="952500" cy="533400"/>
+          </a:xfrm>
+          <a:custGeom>
+            <a:avLst/>
+            <a:gdLst/>
+            <a:ahLst/>
+            <a:cxnLst/>
+            <a:rect l="l" t="t" r="r" b="b"/>
+            <a:pathLst>
+              <a:path w="952500" h="533400">
+                <a:moveTo>
+                  <a:pt x="0" y="84772"/>
+                </a:moveTo>
+                <a:cubicBezTo>
+                  <a:pt x="216218" y="376238"/>
+                  <a:pt x="642938" y="531495"/>
+                  <a:pt x="948690" y="430530"/>
+                </a:cubicBezTo>
+                <a:cubicBezTo>
+                  <a:pt x="780098" y="156210"/>
+                  <a:pt x="353377" y="0"/>
+                  <a:pt x="0" y="84772"/>
+                </a:cubicBezTo>
+                <a:close/>
+              </a:path>
+            </a:pathLst>
+          </a:custGeom>
+          <a:solidFill>
+            <a:srgbClr val="2E9E64"/>
+          </a:solidFill>
+          <a:ln/>
+        </p:spPr>
+      </p:sp>
+      <p:sp>
+        <p:nvSpPr>
+          <p:cNvPr id="20" name=""/>
+          <p:cNvSpPr/>
+          <p:nvPr/>
+        </p:nvSpPr>
+        <p:spPr>
+          <a:xfrm>
+            <a:off x="4352925" y="5591175"/>
+            <a:ext cx="247650" cy="247650"/>
+          </a:xfrm>
+          <a:custGeom>
+            <a:avLst/>
+            <a:gdLst/>
+            <a:ahLst/>
+            <a:cxnLst/>
+            <a:rect l="l" t="t" r="r" b="b"/>
+            <a:pathLst>
+              <a:path w="247650" h="247650">
+                <a:moveTo>
+                  <a:pt x="123825" y="0"/>
+                </a:moveTo>
+                <a:cubicBezTo>
+                  <a:pt x="140970" y="106680"/>
+                  <a:pt x="140970" y="106680"/>
+                  <a:pt x="247650" y="123825"/>
+                </a:cubicBezTo>
+                <a:cubicBezTo>
+                  <a:pt x="140970" y="140970"/>
+                  <a:pt x="140970" y="140970"/>
+                  <a:pt x="123825" y="247650"/>
+                </a:cubicBezTo>
+                <a:cubicBezTo>
+                  <a:pt x="106680" y="140970"/>
+                  <a:pt x="106680" y="140970"/>
+                  <a:pt x="0" y="123825"/>
+                </a:cubicBezTo>
+                <a:cubicBezTo>
+                  <a:pt x="106680" y="106680"/>
+                  <a:pt x="106680" y="106680"/>
+                  <a:pt x="123825" y="0"/>
+                </a:cubicBezTo>
+                <a:close/>
+              </a:path>
+            </a:pathLst>
+          </a:custGeom>
+          <a:solidFill>
+            <a:srgbClr val="FFFFFF"/>
+          </a:solidFill>
+          <a:ln/>
+        </p:spPr>
+      </p:sp>
+      <p:sp>
+        <p:nvSpPr>
+          <p:cNvPr id="21" name=""/>
+          <p:cNvSpPr/>
+          <p:nvPr/>
+        </p:nvSpPr>
+        <p:spPr>
+          <a:xfrm>
+            <a:off x="6486525" y="5838825"/>
+            <a:ext cx="171450" cy="171450"/>
+          </a:xfrm>
+          <a:custGeom>
+            <a:avLst/>
+            <a:gdLst/>
+            <a:ahLst/>
+            <a:cxnLst/>
+            <a:rect l="l" t="t" r="r" b="b"/>
+            <a:pathLst>
+              <a:path w="171450" h="171450">
+                <a:moveTo>
+                  <a:pt x="85725" y="0"/>
+                </a:moveTo>
+                <a:cubicBezTo>
+                  <a:pt x="98107" y="73343"/>
+                  <a:pt x="98107" y="73343"/>
+                  <a:pt x="171450" y="85725"/>
+                </a:cubicBezTo>
+                <a:cubicBezTo>
+                  <a:pt x="98107" y="98107"/>
+                  <a:pt x="98107" y="98107"/>
+                  <a:pt x="85725" y="171450"/>
+                </a:cubicBezTo>
+                <a:cubicBezTo>
+                  <a:pt x="73343" y="98107"/>
+                  <a:pt x="73343" y="98107"/>
+                  <a:pt x="0" y="85725"/>
+                </a:cubicBezTo>
+                <a:cubicBezTo>
+                  <a:pt x="73343" y="73343"/>
+                  <a:pt x="73343" y="73343"/>
+                  <a:pt x="85725" y="0"/>
+                </a:cubicBezTo>
+                <a:close/>
+              </a:path>
+            </a:pathLst>
+          </a:custGeom>
+          <a:solidFill>
+            <a:srgbClr val="FFFFFF"/>
+          </a:solidFill>
+          <a:ln/>
+        </p:spPr>
+      </p:sp>
+      <p:sp>
+        <p:nvSpPr>
+          <p:cNvPr id="22" name=""/>
+          <p:cNvSpPr/>
+          <p:nvPr/>
+        </p:nvSpPr>
+        <p:spPr>
+          <a:xfrm>
+            <a:off x="8086725" y="5572125"/>
+            <a:ext cx="209550" cy="209550"/>
+          </a:xfrm>
+          <a:custGeom>
+            <a:avLst/>
+            <a:gdLst/>
+            <a:ahLst/>
+            <a:cxnLst/>
+            <a:rect l="l" t="t" r="r" b="b"/>
+            <a:pathLst>
+              <a:path w="209550" h="209550">
+                <a:moveTo>
+                  <a:pt x="104775" y="0"/>
+                </a:moveTo>
+                <a:cubicBezTo>
+                  <a:pt x="119062" y="90488"/>
+                  <a:pt x="119062" y="90488"/>
+                  <a:pt x="209550" y="104775"/>
+                </a:cubicBezTo>
+                <a:cubicBezTo>
+                  <a:pt x="119062" y="119062"/>
+                  <a:pt x="119062" y="119062"/>
+                  <a:pt x="104775" y="209550"/>
+                </a:cubicBezTo>
+                <a:cubicBezTo>
+                  <a:pt x="90488" y="119062"/>
+                  <a:pt x="90488" y="119062"/>
+                  <a:pt x="0" y="104775"/>
+                </a:cubicBezTo>
+                <a:cubicBezTo>
+                  <a:pt x="90488" y="90488"/>
+                  <a:pt x="90488" y="90488"/>
+                  <a:pt x="104775" y="0"/>
+                </a:cubicBezTo>
+                <a:close/>
+              </a:path>
+            </a:pathLst>
+          </a:custGeom>
+          <a:solidFill>
+            <a:srgbClr val="FFFFFF"/>
+          </a:solidFill>
+          <a:ln/>
+        </p:spPr>
+      </p:sp>
+      <p:sp>
+        <p:nvSpPr>
+          <p:cNvPr id="23" name=""/>
+          <p:cNvSpPr/>
+          <p:nvPr/>
+        </p:nvSpPr>
+        <p:spPr>
+          <a:xfrm>
+            <a:off x="2190750" y="1647825"/>
+            <a:ext cx="7810500" cy="3524250"/>
+          </a:xfrm>
+          <a:prstGeom prst="roundRect">
+            <a:avLst>
+              <a:gd name="adj" fmla="val 11892"/>
+            </a:avLst>
+          </a:prstGeom>
+          <a:solidFill>
+            <a:srgbClr val="FFFFFF"/>
+          </a:solidFill>
+          <a:ln/>
+          <a:effectLst>
+            <a:outerShdw sx="100000" sy="100000" kx="0" ky="0" algn="bl" rotWithShape="0" blurRad="152400" dist="50800" dir="5400000">
+              <a:srgbClr val="22304A">
+                <a:alpha val="10000"/>
+              </a:srgbClr>
+            </a:outerShdw>
+          </a:effectLst>
+        </p:spPr>
+      </p:sp>
+      <p:sp>
+        <p:nvSpPr>
+          <p:cNvPr id="24" name=""/>
+          <p:cNvSpPr/>
+          <p:nvPr/>
+        </p:nvSpPr>
+        <p:spPr>
+          <a:xfrm>
+            <a:off x="3009900" y="3133725"/>
+            <a:ext cx="6172200" cy="381000"/>
+          </a:xfrm>
+          <a:prstGeom prst="roundRect">
+            <a:avLst>
+              <a:gd name="adj" fmla="val 30000"/>
+            </a:avLst>
+          </a:prstGeom>
+          <a:solidFill>
+            <a:srgbClr val="FFD966"/>
+          </a:solidFill>
+          <a:ln/>
+        </p:spPr>
+      </p:sp>
+      <p:sp>
+        <p:nvSpPr>
+          <p:cNvPr id="25" name=""/>
+          <p:cNvSpPr txBox="1"/>
+          <p:nvPr/>
+        </p:nvSpPr>
+        <p:spPr>
+          <a:xfrm>
+            <a:off x="3143250" y="2076450"/>
+            <a:ext cx="7134225" cy="1657350"/>
+          </a:xfrm>
+          <a:prstGeom prst="rect">
+            <a:avLst/>
+          </a:prstGeom>
+          <a:noFill/>
+          <a:ln/>
+        </p:spPr>
+        <p:txBody>
+          <a:bodyPr wrap="square" lIns="0" tIns="0" rIns="0" bIns="0" anchor="ctr"/>
+          <a:lstStyle/>
+          <a:p>
+            <a:pPr/>
+            <a:r>
+              <a:rPr sz="9000" b="1" spc="360" kern="0">
+                <a:solidFill>
+                  <a:srgbClr val="1A2238"/>
+                </a:solidFill>
+                <a:latin typeface="Noto Sans JP"/>
+                <a:ea typeface="Noto Sans JP"/>
+              </a:rPr>
+              <a:t>塊で覚える</a:t>
+            </a:r>
+          </a:p>
+        </p:txBody>
+      </p:sp>
+      <p:sp>
+        <p:nvSpPr>
+          <p:cNvPr id="26" name=""/>
+          <p:cNvSpPr/>
+          <p:nvPr/>
+        </p:nvSpPr>
+        <p:spPr>
+          <a:xfrm>
+            <a:off x="3838575" y="3800475"/>
+            <a:ext cx="4524375" cy="800100"/>
+          </a:xfrm>
+          <a:prstGeom prst="roundRect">
+            <a:avLst>
+              <a:gd name="adj" fmla="val 50000"/>
+            </a:avLst>
+          </a:prstGeom>
+          <a:solidFill>
+            <a:srgbClr val="F0521E"/>
+          </a:solidFill>
+          <a:ln/>
+        </p:spPr>
+      </p:sp>
+      <p:sp>
+        <p:nvSpPr>
+          <p:cNvPr id="27" name=""/>
+          <p:cNvSpPr txBox="1"/>
+          <p:nvPr/>
+        </p:nvSpPr>
+        <p:spPr>
+          <a:xfrm>
+            <a:off x="4257675" y="3914775"/>
+            <a:ext cx="4581525" cy="552450"/>
+          </a:xfrm>
+          <a:prstGeom prst="rect">
+            <a:avLst/>
+          </a:prstGeom>
+          <a:noFill/>
+          <a:ln/>
+        </p:spPr>
+        <p:txBody>
+          <a:bodyPr wrap="square" lIns="0" tIns="0" rIns="0" bIns="0" anchor="ctr"/>
+          <a:lstStyle/>
+          <a:p>
+            <a:pPr/>
+            <a:r>
+              <a:rPr sz="3000" b="1" spc="240" kern="0">
+                <a:solidFill>
+                  <a:srgbClr val="FFFFFF"/>
+                </a:solidFill>
+                <a:latin typeface="Noto Sans JP"/>
+                <a:ea typeface="Noto Sans JP"/>
+              </a:rPr>
+              <a:t>日常英会話フレーズ</a:t>
+            </a:r>
+          </a:p>
+        </p:txBody>
+      </p:sp>
+      <p:sp>
+        <p:nvSpPr>
+          <p:cNvPr id="28" name=""/>
+          <p:cNvSpPr/>
+          <p:nvPr/>
+        </p:nvSpPr>
+        <p:spPr>
+          <a:xfrm>
+            <a:off x="1390650" y="4905375"/>
+            <a:ext cx="857250" cy="609600"/>
+          </a:xfrm>
+          <a:custGeom>
+            <a:avLst/>
+            <a:gdLst/>
+            <a:ahLst/>
+            <a:cxnLst/>
+            <a:rect l="l" t="t" r="r" b="b"/>
+            <a:pathLst>
+              <a:path w="857250" h="609600">
+                <a:moveTo>
+                  <a:pt x="859155" y="139065"/>
+                </a:moveTo>
+                <a:cubicBezTo>
+                  <a:pt x="516255" y="0"/>
+                  <a:pt x="129540" y="140970"/>
+                  <a:pt x="0" y="451485"/>
+                </a:cubicBezTo>
+                <a:cubicBezTo>
+                  <a:pt x="299085" y="606743"/>
+                  <a:pt x="685800" y="465772"/>
+                  <a:pt x="859155" y="139065"/>
+                </a:cubicBezTo>
+                <a:close/>
+              </a:path>
+            </a:pathLst>
+          </a:custGeom>
+          <a:solidFill>
+            <a:srgbClr val="2E9E64"/>
+          </a:solidFill>
+          <a:ln/>
+        </p:spPr>
+      </p:sp>
+      <p:sp>
+        <p:nvSpPr>
+          <p:cNvPr id="29" name=""/>
+          <p:cNvSpPr/>
+          <p:nvPr/>
+        </p:nvSpPr>
+        <p:spPr>
+          <a:xfrm>
+            <a:off x="1581150" y="4505325"/>
+            <a:ext cx="666750" cy="590550"/>
+          </a:xfrm>
+          <a:custGeom>
+            <a:avLst/>
+            <a:gdLst/>
+            <a:ahLst/>
+            <a:cxnLst/>
+            <a:rect l="l" t="t" r="r" b="b"/>
+            <a:pathLst>
+              <a:path w="666750" h="590550">
+                <a:moveTo>
+                  <a:pt x="670560" y="540067"/>
+                </a:moveTo>
+                <a:cubicBezTo>
+                  <a:pt x="600075" y="211455"/>
+                  <a:pt x="298133" y="0"/>
+                  <a:pt x="0" y="70485"/>
+                </a:cubicBezTo>
+                <a:cubicBezTo>
+                  <a:pt x="36195" y="375285"/>
+                  <a:pt x="338137" y="586740"/>
+                  <a:pt x="670560" y="540067"/>
+                </a:cubicBezTo>
+                <a:close/>
+              </a:path>
+            </a:pathLst>
+          </a:custGeom>
+          <a:solidFill>
+            <a:srgbClr val="23824F"/>
+          </a:solidFill>
+          <a:ln/>
+        </p:spPr>
+      </p:sp>
+      <p:sp>
+        <p:nvSpPr>
+          <p:cNvPr id="30" name=""/>
+          <p:cNvSpPr/>
+          <p:nvPr/>
+        </p:nvSpPr>
+        <p:spPr>
+          <a:xfrm>
+            <a:off x="1905000" y="4352925"/>
+            <a:ext cx="781050" cy="695325"/>
+          </a:xfrm>
+          <a:custGeom>
+            <a:avLst/>
+            <a:gdLst/>
+            <a:ahLst/>
+            <a:cxnLst/>
+            <a:rect l="l" t="t" r="r" b="b"/>
+            <a:pathLst>
+              <a:path w="781050" h="695325">
+                <a:moveTo>
+                  <a:pt x="344805" y="697230"/>
+                </a:moveTo>
+                <a:cubicBezTo>
+                  <a:pt x="721042" y="673417"/>
+                  <a:pt x="782002" y="114300"/>
+                  <a:pt x="447675" y="115252"/>
+                </a:cubicBezTo>
+                <a:cubicBezTo>
+                  <a:pt x="133350" y="0"/>
+                  <a:pt x="0" y="546735"/>
+                  <a:pt x="344805" y="697230"/>
+                </a:cubicBezTo>
+                <a:close/>
+              </a:path>
+            </a:pathLst>
+          </a:custGeom>
+          <a:solidFill>
+            <a:srgbClr val="E8364E"/>
+          </a:solidFill>
+          <a:ln/>
+        </p:spPr>
+      </p:sp>
+      <p:sp>
+        <p:nvSpPr>
+          <p:cNvPr id="31" name=""/>
+          <p:cNvSpPr/>
+          <p:nvPr/>
+        </p:nvSpPr>
+        <p:spPr>
+          <a:xfrm>
+            <a:off x="2247900" y="4629150"/>
+            <a:ext cx="685800" cy="771525"/>
+          </a:xfrm>
+          <a:custGeom>
+            <a:avLst/>
+            <a:gdLst/>
+            <a:ahLst/>
+            <a:cxnLst/>
+            <a:rect l="l" t="t" r="r" b="b"/>
+            <a:pathLst>
+              <a:path w="685800" h="771525">
+                <a:moveTo>
+                  <a:pt x="0" y="417195"/>
+                </a:moveTo>
+                <a:cubicBezTo>
+                  <a:pt x="139065" y="767715"/>
+                  <a:pt x="689610" y="653415"/>
+                  <a:pt x="584835" y="335280"/>
+                </a:cubicBezTo>
+                <a:cubicBezTo>
+                  <a:pt x="597217" y="0"/>
+                  <a:pt x="37148" y="41910"/>
+                  <a:pt x="0" y="417195"/>
+                </a:cubicBezTo>
+                <a:close/>
+              </a:path>
+            </a:pathLst>
+          </a:custGeom>
+          <a:solidFill>
+            <a:srgbClr val="E8364E"/>
+          </a:solidFill>
+          <a:ln/>
+        </p:spPr>
+      </p:sp>
+      <p:sp>
+        <p:nvSpPr>
+          <p:cNvPr id="32" name=""/>
+          <p:cNvSpPr/>
+          <p:nvPr/>
+        </p:nvSpPr>
+        <p:spPr>
+          <a:xfrm>
+            <a:off x="1962150" y="4972050"/>
+            <a:ext cx="876300" cy="809625"/>
+          </a:xfrm>
+          <a:custGeom>
+            <a:avLst/>
+            <a:gdLst/>
+            <a:ahLst/>
+            <a:cxnLst/>
+            <a:rect l="l" t="t" r="r" b="b"/>
+            <a:pathLst>
+              <a:path w="876300" h="809625">
+                <a:moveTo>
+                  <a:pt x="290513" y="80962"/>
+                </a:moveTo>
+                <a:cubicBezTo>
+                  <a:pt x="0" y="320993"/>
+                  <a:pt x="279083" y="809625"/>
+                  <a:pt x="549592" y="611505"/>
+                </a:cubicBezTo>
+                <a:cubicBezTo>
+                  <a:pt x="871538" y="520065"/>
+                  <a:pt x="658178" y="0"/>
+                  <a:pt x="290513" y="80962"/>
+                </a:cubicBezTo>
+                <a:close/>
+              </a:path>
+            </a:pathLst>
+          </a:custGeom>
+          <a:solidFill>
+            <a:srgbClr val="E8364E"/>
+          </a:solidFill>
+          <a:ln/>
+        </p:spPr>
+      </p:sp>
+      <p:sp>
+        <p:nvSpPr>
+          <p:cNvPr id="33" name=""/>
+          <p:cNvSpPr/>
+          <p:nvPr/>
+        </p:nvSpPr>
+        <p:spPr>
+          <a:xfrm>
+            <a:off x="1552575" y="4848225"/>
+            <a:ext cx="885825" cy="885825"/>
+          </a:xfrm>
+          <a:custGeom>
+            <a:avLst/>
+            <a:gdLst/>
+            <a:ahLst/>
+            <a:cxnLst/>
+            <a:rect l="l" t="t" r="r" b="b"/>
+            <a:pathLst>
+              <a:path w="885825" h="885825">
+                <a:moveTo>
+                  <a:pt x="696277" y="201930"/>
+                </a:moveTo>
+                <a:cubicBezTo>
+                  <a:pt x="378142" y="0"/>
+                  <a:pt x="0" y="416242"/>
+                  <a:pt x="271463" y="612458"/>
+                </a:cubicBezTo>
+                <a:cubicBezTo>
+                  <a:pt x="458152" y="890587"/>
+                  <a:pt x="886778" y="526733"/>
+                  <a:pt x="696277" y="201930"/>
+                </a:cubicBezTo>
+                <a:close/>
+              </a:path>
+            </a:pathLst>
+          </a:custGeom>
+          <a:solidFill>
+            <a:srgbClr val="E8364E"/>
+          </a:solidFill>
+          <a:ln/>
+        </p:spPr>
+      </p:sp>
+      <p:sp>
+        <p:nvSpPr>
+          <p:cNvPr id="34" name=""/>
+          <p:cNvSpPr/>
+          <p:nvPr/>
+        </p:nvSpPr>
+        <p:spPr>
+          <a:xfrm>
+            <a:off x="1524000" y="4448175"/>
+            <a:ext cx="819150" cy="876300"/>
+          </a:xfrm>
+          <a:custGeom>
+            <a:avLst/>
+            <a:gdLst/>
+            <a:ahLst/>
+            <a:cxnLst/>
+            <a:rect l="l" t="t" r="r" b="b"/>
+            <a:pathLst>
+              <a:path w="819150" h="876300">
+                <a:moveTo>
+                  <a:pt x="728663" y="596265"/>
+                </a:moveTo>
+                <a:cubicBezTo>
+                  <a:pt x="822008" y="231458"/>
+                  <a:pt x="309562" y="0"/>
+                  <a:pt x="207645" y="319088"/>
+                </a:cubicBezTo>
+                <a:cubicBezTo>
+                  <a:pt x="0" y="581978"/>
+                  <a:pt x="478155" y="878205"/>
+                  <a:pt x="728663" y="596265"/>
+                </a:cubicBezTo>
+                <a:close/>
+              </a:path>
+            </a:pathLst>
+          </a:custGeom>
+          <a:solidFill>
+            <a:srgbClr val="E8364E"/>
+          </a:solidFill>
+          <a:ln/>
+        </p:spPr>
+      </p:sp>
+      <p:sp>
+        <p:nvSpPr>
+          <p:cNvPr id="35" name=""/>
+          <p:cNvSpPr/>
+          <p:nvPr/>
+        </p:nvSpPr>
+        <p:spPr>
+          <a:xfrm>
+            <a:off x="2133600" y="4933950"/>
+            <a:ext cx="238125" cy="238125"/>
+          </a:xfrm>
+          <a:custGeom>
+            <a:avLst/>
+            <a:gdLst/>
+            <a:ahLst/>
+            <a:cxnLst/>
+            <a:rect l="l" t="t" r="r" b="b"/>
+            <a:pathLst>
+              <a:path w="238125" h="238125">
+                <a:moveTo>
+                  <a:pt x="236220" y="118110"/>
+                </a:moveTo>
+                <a:cubicBezTo>
+                  <a:pt x="236220" y="182880"/>
+                  <a:pt x="182880" y="236220"/>
+                  <a:pt x="118110" y="236220"/>
+                </a:cubicBezTo>
+                <a:cubicBezTo>
+                  <a:pt x="53340" y="236220"/>
+                  <a:pt x="0" y="182880"/>
+                  <a:pt x="0" y="118110"/>
+                </a:cubicBezTo>
+                <a:cubicBezTo>
+                  <a:pt x="0" y="53340"/>
+                  <a:pt x="53340" y="0"/>
+                  <a:pt x="118110" y="0"/>
+                </a:cubicBezTo>
+                <a:cubicBezTo>
+                  <a:pt x="182880" y="0"/>
+                  <a:pt x="236220" y="53340"/>
+                  <a:pt x="236220" y="118110"/>
+                </a:cubicBezTo>
+                <a:close/>
+              </a:path>
+            </a:pathLst>
+          </a:custGeom>
+          <a:solidFill>
+            <a:srgbClr val="B5173A"/>
+          </a:solidFill>
+          <a:ln/>
+        </p:spPr>
+      </p:sp>
+      <p:sp>
+        <p:nvSpPr>
+          <p:cNvPr id="36" name=""/>
+          <p:cNvSpPr/>
+          <p:nvPr/>
+        </p:nvSpPr>
+        <p:spPr>
+          <a:xfrm>
+            <a:off x="2247900" y="4724400"/>
+            <a:ext cx="342900" cy="333375"/>
+          </a:xfrm>
+          <a:custGeom>
+            <a:avLst/>
+            <a:gdLst/>
+            <a:ahLst/>
+            <a:cxnLst/>
+            <a:rect l="l" t="t" r="r" b="b"/>
+            <a:pathLst>
+              <a:path w="342900" h="333375">
+                <a:moveTo>
+                  <a:pt x="0" y="328613"/>
+                </a:moveTo>
+                <a:cubicBezTo>
+                  <a:pt x="122873" y="251460"/>
+                  <a:pt x="275272" y="103822"/>
+                  <a:pt x="340042" y="0"/>
+                </a:cubicBezTo>
+                <a:cubicBezTo>
+                  <a:pt x="234315" y="60960"/>
+                  <a:pt x="81915" y="208597"/>
+                  <a:pt x="0" y="328613"/>
+                </a:cubicBezTo>
+                <a:close/>
+              </a:path>
+            </a:pathLst>
+          </a:custGeom>
+          <a:solidFill>
+            <a:srgbClr val="B5173A"/>
+          </a:solidFill>
+          <a:ln/>
+        </p:spPr>
+      </p:sp>
+      <p:sp>
+        <p:nvSpPr>
+          <p:cNvPr id="37" name=""/>
+          <p:cNvSpPr/>
+          <p:nvPr/>
+        </p:nvSpPr>
+        <p:spPr>
+          <a:xfrm>
+            <a:off x="2533650" y="4667250"/>
+            <a:ext cx="104775" cy="104775"/>
+          </a:xfrm>
+          <a:custGeom>
+            <a:avLst/>
+            <a:gdLst/>
+            <a:ahLst/>
+            <a:cxnLst/>
+            <a:rect l="l" t="t" r="r" b="b"/>
+            <a:pathLst>
+              <a:path w="104775" h="104775">
+                <a:moveTo>
+                  <a:pt x="106680" y="52388"/>
+                </a:moveTo>
+                <a:cubicBezTo>
+                  <a:pt x="106680" y="81915"/>
+                  <a:pt x="82867" y="105728"/>
+                  <a:pt x="53340" y="105728"/>
+                </a:cubicBezTo>
+                <a:cubicBezTo>
+                  <a:pt x="23812" y="105728"/>
+                  <a:pt x="0" y="81915"/>
+                  <a:pt x="0" y="52388"/>
+                </a:cubicBezTo>
+                <a:cubicBezTo>
+                  <a:pt x="0" y="23812"/>
+                  <a:pt x="23812" y="0"/>
+                  <a:pt x="53340" y="0"/>
+                </a:cubicBezTo>
+                <a:cubicBezTo>
+                  <a:pt x="82867" y="0"/>
+                  <a:pt x="106680" y="23812"/>
+                  <a:pt x="106680" y="52388"/>
+                </a:cubicBezTo>
+                <a:close/>
+              </a:path>
+            </a:pathLst>
+          </a:custGeom>
+          <a:solidFill>
+            <a:srgbClr val="FFD24A"/>
+          </a:solidFill>
+          <a:ln/>
+        </p:spPr>
+      </p:sp>
+      <p:sp>
+        <p:nvSpPr>
+          <p:cNvPr id="38" name=""/>
+          <p:cNvSpPr/>
+          <p:nvPr/>
+        </p:nvSpPr>
+        <p:spPr>
+          <a:xfrm>
+            <a:off x="9448800" y="1304925"/>
+            <a:ext cx="571500" cy="419100"/>
+          </a:xfrm>
+          <a:custGeom>
+            <a:avLst/>
+            <a:gdLst/>
+            <a:ahLst/>
+            <a:cxnLst/>
+            <a:rect l="l" t="t" r="r" b="b"/>
+            <a:pathLst>
+              <a:path w="571500" h="419100">
+                <a:moveTo>
+                  <a:pt x="572453" y="317183"/>
+                </a:moveTo>
+                <a:cubicBezTo>
+                  <a:pt x="459105" y="93345"/>
+                  <a:pt x="201930" y="0"/>
+                  <a:pt x="0" y="108585"/>
+                </a:cubicBezTo>
+                <a:cubicBezTo>
+                  <a:pt x="83820" y="321945"/>
+                  <a:pt x="341947" y="415290"/>
+                  <a:pt x="572453" y="317183"/>
+                </a:cubicBezTo>
+                <a:close/>
+              </a:path>
+            </a:pathLst>
+          </a:custGeom>
+          <a:solidFill>
+            <a:srgbClr val="2E9E64"/>
+          </a:solidFill>
+          <a:ln/>
+        </p:spPr>
+      </p:sp>
+      <p:sp>
+        <p:nvSpPr>
+          <p:cNvPr id="39" name=""/>
+          <p:cNvSpPr/>
+          <p:nvPr/>
+        </p:nvSpPr>
+        <p:spPr>
+          <a:xfrm>
+            <a:off x="9715500" y="1162050"/>
+            <a:ext cx="523875" cy="457200"/>
+          </a:xfrm>
+          <a:custGeom>
+            <a:avLst/>
+            <a:gdLst/>
+            <a:ahLst/>
+            <a:cxnLst/>
+            <a:rect l="l" t="t" r="r" b="b"/>
+            <a:pathLst>
+              <a:path w="523875" h="457200">
+                <a:moveTo>
+                  <a:pt x="307657" y="458152"/>
+                </a:moveTo>
+                <a:cubicBezTo>
+                  <a:pt x="522922" y="345757"/>
+                  <a:pt x="412432" y="0"/>
+                  <a:pt x="215265" y="88582"/>
+                </a:cubicBezTo>
+                <a:cubicBezTo>
+                  <a:pt x="0" y="102870"/>
+                  <a:pt x="64770" y="460057"/>
+                  <a:pt x="307657" y="458152"/>
+                </a:cubicBezTo>
+                <a:close/>
+              </a:path>
+            </a:pathLst>
+          </a:custGeom>
+          <a:solidFill>
+            <a:srgbClr val="FF6F91"/>
+          </a:solidFill>
+          <a:ln/>
+        </p:spPr>
+      </p:sp>
+      <p:sp>
+        <p:nvSpPr>
+          <p:cNvPr id="40" name=""/>
+          <p:cNvSpPr/>
+          <p:nvPr/>
+        </p:nvSpPr>
+        <p:spPr>
+          <a:xfrm>
+            <a:off x="9944100" y="1219200"/>
+            <a:ext cx="542925" cy="571500"/>
+          </a:xfrm>
+          <a:custGeom>
+            <a:avLst/>
+            <a:gdLst/>
+            <a:ahLst/>
+            <a:cxnLst/>
+            <a:rect l="l" t="t" r="r" b="b"/>
+            <a:pathLst>
+              <a:path w="542925" h="571500">
+                <a:moveTo>
+                  <a:pt x="77152" y="401955"/>
+                </a:moveTo>
+                <a:cubicBezTo>
+                  <a:pt x="250507" y="572453"/>
+                  <a:pt x="544830" y="360045"/>
+                  <a:pt x="400050" y="200025"/>
+                </a:cubicBezTo>
+                <a:cubicBezTo>
+                  <a:pt x="320040" y="0"/>
+                  <a:pt x="0" y="171450"/>
+                  <a:pt x="77152" y="401955"/>
+                </a:cubicBezTo>
+                <a:close/>
+              </a:path>
+            </a:pathLst>
+          </a:custGeom>
+          <a:solidFill>
+            <a:srgbClr val="FF6F91"/>
+          </a:solidFill>
+          <a:ln/>
+        </p:spPr>
+      </p:sp>
+      <p:sp>
+        <p:nvSpPr>
+          <p:cNvPr id="41" name=""/>
+          <p:cNvSpPr/>
+          <p:nvPr/>
+        </p:nvSpPr>
+        <p:spPr>
+          <a:xfrm>
+            <a:off x="9915525" y="1476375"/>
+            <a:ext cx="561975" cy="581025"/>
+          </a:xfrm>
+          <a:custGeom>
+            <a:avLst/>
+            <a:gdLst/>
+            <a:ahLst/>
+            <a:cxnLst/>
+            <a:rect l="l" t="t" r="r" b="b"/>
+            <a:pathLst>
+              <a:path w="561975" h="581025">
+                <a:moveTo>
+                  <a:pt x="107632" y="143827"/>
+                </a:moveTo>
+                <a:cubicBezTo>
+                  <a:pt x="0" y="361950"/>
+                  <a:pt x="292418" y="576262"/>
+                  <a:pt x="399097" y="388620"/>
+                </a:cubicBezTo>
+                <a:cubicBezTo>
+                  <a:pt x="565785" y="250507"/>
+                  <a:pt x="302895" y="0"/>
+                  <a:pt x="107632" y="143827"/>
+                </a:cubicBezTo>
+                <a:close/>
+              </a:path>
+            </a:pathLst>
+          </a:custGeom>
+          <a:solidFill>
+            <a:srgbClr val="FF6F91"/>
+          </a:solidFill>
+          <a:ln/>
+        </p:spPr>
+      </p:sp>
+      <p:sp>
+        <p:nvSpPr>
+          <p:cNvPr id="42" name=""/>
+          <p:cNvSpPr/>
+          <p:nvPr/>
+        </p:nvSpPr>
+        <p:spPr>
+          <a:xfrm>
+            <a:off x="9667875" y="1581150"/>
+            <a:ext cx="552450" cy="504825"/>
+          </a:xfrm>
+          <a:custGeom>
+            <a:avLst/>
+            <a:gdLst/>
+            <a:ahLst/>
+            <a:cxnLst/>
+            <a:rect l="l" t="t" r="r" b="b"/>
+            <a:pathLst>
+              <a:path w="552450" h="504825">
+                <a:moveTo>
+                  <a:pt x="354330" y="35242"/>
+                </a:moveTo>
+                <a:cubicBezTo>
+                  <a:pt x="114300" y="0"/>
+                  <a:pt x="0" y="343852"/>
+                  <a:pt x="211455" y="388620"/>
+                </a:cubicBezTo>
+                <a:cubicBezTo>
+                  <a:pt x="394335" y="503872"/>
+                  <a:pt x="551498" y="177165"/>
+                  <a:pt x="354330" y="35242"/>
+                </a:cubicBezTo>
+                <a:close/>
+              </a:path>
+            </a:pathLst>
+          </a:custGeom>
+          <a:solidFill>
+            <a:srgbClr val="FF6F91"/>
+          </a:solidFill>
+          <a:ln/>
+        </p:spPr>
+      </p:sp>
+      <p:sp>
+        <p:nvSpPr>
+          <p:cNvPr id="43" name=""/>
+          <p:cNvSpPr/>
+          <p:nvPr/>
+        </p:nvSpPr>
+        <p:spPr>
+          <a:xfrm>
+            <a:off x="9591675" y="1381125"/>
+            <a:ext cx="428625" cy="476250"/>
+          </a:xfrm>
+          <a:custGeom>
+            <a:avLst/>
+            <a:gdLst/>
+            <a:ahLst/>
+            <a:cxnLst/>
+            <a:rect l="l" t="t" r="r" b="b"/>
+            <a:pathLst>
+              <a:path w="428625" h="476250">
+                <a:moveTo>
+                  <a:pt x="432435" y="240983"/>
+                </a:moveTo>
+                <a:cubicBezTo>
+                  <a:pt x="391478" y="953"/>
+                  <a:pt x="29528" y="0"/>
+                  <a:pt x="52388" y="214313"/>
+                </a:cubicBezTo>
+                <a:cubicBezTo>
+                  <a:pt x="0" y="423862"/>
+                  <a:pt x="359092" y="472440"/>
+                  <a:pt x="432435" y="240983"/>
+                </a:cubicBezTo>
+                <a:close/>
+              </a:path>
+            </a:pathLst>
+          </a:custGeom>
+          <a:solidFill>
+            <a:srgbClr val="FF6F91"/>
+          </a:solidFill>
+          <a:ln/>
+        </p:spPr>
+      </p:sp>
+      <p:sp>
+        <p:nvSpPr>
+          <p:cNvPr id="44" name=""/>
+          <p:cNvSpPr/>
+          <p:nvPr/>
+        </p:nvSpPr>
+        <p:spPr>
+          <a:xfrm>
+            <a:off x="9944100" y="1543050"/>
             <a:ext cx="152400" cy="152400"/>
           </a:xfrm>
           <a:custGeom>
@@ -903,21 +3248,21 @@
             </a:pathLst>
           </a:custGeom>
           <a:solidFill>
-            <a:srgbClr val="FF8A57"/>
-          </a:solidFill>
-          <a:ln/>
-        </p:spPr>
-      </p:sp>
-      <p:sp>
-        <p:nvSpPr>
-          <p:cNvPr id="10" name=""/>
-          <p:cNvSpPr/>
-          <p:nvPr/>
-        </p:nvSpPr>
-        <p:spPr>
-          <a:xfrm>
-            <a:off x="7124700" y="5981700"/>
-            <a:ext cx="228600" cy="228600"/>
+            <a:srgbClr val="D63A6A"/>
+          </a:solidFill>
+          <a:ln/>
+        </p:spPr>
+      </p:sp>
+      <p:sp>
+        <p:nvSpPr>
+          <p:cNvPr id="45" name=""/>
+          <p:cNvSpPr/>
+          <p:nvPr/>
+        </p:nvSpPr>
+        <p:spPr>
+          <a:xfrm>
+            <a:off x="10020300" y="1333500"/>
+            <a:ext cx="114300" cy="285750"/>
           </a:xfrm>
           <a:custGeom>
             <a:avLst/>
@@ -926,50 +3271,40 @@
             <a:cxnLst/>
             <a:rect l="l" t="t" r="r" b="b"/>
             <a:pathLst>
-              <a:path w="228600" h="228600">
+              <a:path w="114300" h="285750">
                 <a:moveTo>
-                  <a:pt x="228600" y="114300"/>
+                  <a:pt x="0" y="282892"/>
                 </a:moveTo>
                 <a:cubicBezTo>
-                  <a:pt x="228600" y="177165"/>
-                  <a:pt x="177165" y="228600"/>
-                  <a:pt x="114300" y="228600"/>
-                </a:cubicBezTo>
-                <a:cubicBezTo>
-                  <a:pt x="51435" y="228600"/>
-                  <a:pt x="0" y="177165"/>
-                  <a:pt x="0" y="114300"/>
-                </a:cubicBezTo>
-                <a:cubicBezTo>
-                  <a:pt x="0" y="51435"/>
-                  <a:pt x="51435" y="0"/>
+                  <a:pt x="52388" y="204787"/>
+                  <a:pt x="102870" y="78105"/>
                   <a:pt x="114300" y="0"/>
                 </a:cubicBezTo>
                 <a:cubicBezTo>
-                  <a:pt x="177165" y="0"/>
-                  <a:pt x="228600" y="51435"/>
-                  <a:pt x="228600" y="114300"/>
+                  <a:pt x="67627" y="63817"/>
+                  <a:pt x="16193" y="190500"/>
+                  <a:pt x="0" y="282892"/>
                 </a:cubicBezTo>
                 <a:close/>
               </a:path>
             </a:pathLst>
           </a:custGeom>
           <a:solidFill>
-            <a:srgbClr val="FF9DB4"/>
-          </a:solidFill>
-          <a:ln/>
-        </p:spPr>
-      </p:sp>
-      <p:sp>
-        <p:nvSpPr>
-          <p:cNvPr id="11" name=""/>
-          <p:cNvSpPr/>
-          <p:nvPr/>
-        </p:nvSpPr>
-        <p:spPr>
-          <a:xfrm>
-            <a:off x="3914775" y="6124575"/>
-            <a:ext cx="171450" cy="171450"/>
+            <a:srgbClr val="D63A6A"/>
+          </a:solidFill>
+          <a:ln/>
+        </p:spPr>
+      </p:sp>
+      <p:sp>
+        <p:nvSpPr>
+          <p:cNvPr id="46" name=""/>
+          <p:cNvSpPr/>
+          <p:nvPr/>
+        </p:nvSpPr>
+        <p:spPr>
+          <a:xfrm>
+            <a:off x="10096500" y="1304925"/>
+            <a:ext cx="66675" cy="66675"/>
           </a:xfrm>
           <a:custGeom>
             <a:avLst/>
@@ -978,387 +3313,36 @@
             <a:cxnLst/>
             <a:rect l="l" t="t" r="r" b="b"/>
             <a:pathLst>
-              <a:path w="171450" h="171450">
+              <a:path w="66675" h="66675">
                 <a:moveTo>
-                  <a:pt x="171450" y="85725"/>
+                  <a:pt x="68580" y="34290"/>
                 </a:moveTo>
                 <a:cubicBezTo>
-                  <a:pt x="171450" y="133350"/>
-                  <a:pt x="133350" y="171450"/>
-                  <a:pt x="85725" y="171450"/>
+                  <a:pt x="68580" y="53340"/>
+                  <a:pt x="53340" y="68580"/>
+                  <a:pt x="34290" y="68580"/>
                 </a:cubicBezTo>
                 <a:cubicBezTo>
-                  <a:pt x="38100" y="171450"/>
-                  <a:pt x="0" y="133350"/>
-                  <a:pt x="0" y="85725"/>
+                  <a:pt x="15240" y="68580"/>
+                  <a:pt x="0" y="53340"/>
+                  <a:pt x="0" y="34290"/>
                 </a:cubicBezTo>
                 <a:cubicBezTo>
-                  <a:pt x="0" y="38100"/>
-                  <a:pt x="38100" y="0"/>
-                  <a:pt x="85725" y="0"/>
+                  <a:pt x="0" y="15240"/>
+                  <a:pt x="15240" y="0"/>
+                  <a:pt x="34290" y="0"/>
                 </a:cubicBezTo>
                 <a:cubicBezTo>
-                  <a:pt x="133350" y="0"/>
-                  <a:pt x="171450" y="38100"/>
-                  <a:pt x="171450" y="85725"/>
+                  <a:pt x="53340" y="0"/>
+                  <a:pt x="68580" y="15240"/>
+                  <a:pt x="68580" y="34290"/>
                 </a:cubicBezTo>
                 <a:close/>
               </a:path>
             </a:pathLst>
           </a:custGeom>
           <a:solidFill>
-            <a:srgbClr val="7DBDEB"/>
-          </a:solidFill>
-          <a:ln/>
-        </p:spPr>
-      </p:sp>
-      <p:sp>
-        <p:nvSpPr>
-          <p:cNvPr id="12" name=""/>
-          <p:cNvSpPr/>
-          <p:nvPr/>
-        </p:nvSpPr>
-        <p:spPr>
-          <a:xfrm>
-            <a:off x="2000250" y="1504950"/>
-            <a:ext cx="8191500" cy="3810000"/>
-          </a:xfrm>
-          <a:prstGeom prst="roundRect">
-            <a:avLst>
-              <a:gd name="adj" fmla="val 11000"/>
-            </a:avLst>
-          </a:prstGeom>
-          <a:solidFill>
-            <a:srgbClr val="FFFFFF"/>
-          </a:solidFill>
-          <a:ln/>
-          <a:effectLst>
-            <a:outerShdw sx="100000" sy="100000" kx="0" ky="0" algn="bl" rotWithShape="0" blurRad="152400" dist="50800" dir="5400000">
-              <a:srgbClr val="22304A">
-                <a:alpha val="10000"/>
-              </a:srgbClr>
-            </a:outerShdw>
-          </a:effectLst>
-        </p:spPr>
-      </p:sp>
-      <p:sp>
-        <p:nvSpPr>
-          <p:cNvPr id="13" name=""/>
-          <p:cNvSpPr/>
-          <p:nvPr/>
-        </p:nvSpPr>
-        <p:spPr>
-          <a:xfrm>
-            <a:off x="3009900" y="3133725"/>
-            <a:ext cx="6172200" cy="381000"/>
-          </a:xfrm>
-          <a:prstGeom prst="roundRect">
-            <a:avLst>
-              <a:gd name="adj" fmla="val 30000"/>
-            </a:avLst>
-          </a:prstGeom>
-          <a:solidFill>
-            <a:srgbClr val="FFD966"/>
-          </a:solidFill>
-          <a:ln/>
-        </p:spPr>
-      </p:sp>
-      <p:sp>
-        <p:nvSpPr>
-          <p:cNvPr id="14" name=""/>
-          <p:cNvSpPr txBox="1"/>
-          <p:nvPr/>
-        </p:nvSpPr>
-        <p:spPr>
-          <a:xfrm>
-            <a:off x="3143250" y="2076450"/>
-            <a:ext cx="7134225" cy="1657350"/>
-          </a:xfrm>
-          <a:prstGeom prst="rect">
-            <a:avLst/>
-          </a:prstGeom>
-          <a:noFill/>
-          <a:ln/>
-        </p:spPr>
-        <p:txBody>
-          <a:bodyPr wrap="square" lIns="0" tIns="0" rIns="0" bIns="0" anchor="ctr"/>
-          <a:lstStyle/>
-          <a:p>
-            <a:pPr/>
-            <a:r>
-              <a:rPr sz="9000" b="1" spc="360" kern="0">
-                <a:solidFill>
-                  <a:srgbClr val="1A2238"/>
-                </a:solidFill>
-                <a:latin typeface="Noto Sans JP"/>
-                <a:ea typeface="Noto Sans JP"/>
-              </a:rPr>
-              <a:t>塊で覚える</a:t>
-            </a:r>
-          </a:p>
-        </p:txBody>
-      </p:sp>
-      <p:sp>
-        <p:nvSpPr>
-          <p:cNvPr id="15" name=""/>
-          <p:cNvSpPr/>
-          <p:nvPr/>
-        </p:nvSpPr>
-        <p:spPr>
-          <a:xfrm>
-            <a:off x="3838575" y="3800475"/>
-            <a:ext cx="4524375" cy="800100"/>
-          </a:xfrm>
-          <a:prstGeom prst="roundRect">
-            <a:avLst>
-              <a:gd name="adj" fmla="val 50000"/>
-            </a:avLst>
-          </a:prstGeom>
-          <a:solidFill>
-            <a:srgbClr val="F0521E"/>
-          </a:solidFill>
-          <a:ln/>
-        </p:spPr>
-      </p:sp>
-      <p:sp>
-        <p:nvSpPr>
-          <p:cNvPr id="16" name=""/>
-          <p:cNvSpPr txBox="1"/>
-          <p:nvPr/>
-        </p:nvSpPr>
-        <p:spPr>
-          <a:xfrm>
-            <a:off x="4257675" y="3914775"/>
-            <a:ext cx="4581525" cy="552450"/>
-          </a:xfrm>
-          <a:prstGeom prst="rect">
-            <a:avLst/>
-          </a:prstGeom>
-          <a:noFill/>
-          <a:ln/>
-        </p:spPr>
-        <p:txBody>
-          <a:bodyPr wrap="square" lIns="0" tIns="0" rIns="0" bIns="0" anchor="ctr"/>
-          <a:lstStyle/>
-          <a:p>
-            <a:pPr/>
-            <a:r>
-              <a:rPr sz="3000" b="1" spc="240" kern="0">
-                <a:solidFill>
-                  <a:srgbClr val="FFFFFF"/>
-                </a:solidFill>
-                <a:latin typeface="Noto Sans JP"/>
-                <a:ea typeface="Noto Sans JP"/>
-              </a:rPr>
-              <a:t>日常英会話フレーズ</a:t>
-            </a:r>
-          </a:p>
-        </p:txBody>
-      </p:sp>
-      <p:sp>
-        <p:nvSpPr>
-          <p:cNvPr id="17" name=""/>
-          <p:cNvSpPr/>
-          <p:nvPr/>
-        </p:nvSpPr>
-        <p:spPr>
-          <a:xfrm>
-            <a:off x="9696450" y="1352550"/>
-            <a:ext cx="647700" cy="647700"/>
-          </a:xfrm>
-          <a:custGeom>
-            <a:avLst/>
-            <a:gdLst/>
-            <a:ahLst/>
-            <a:cxnLst/>
-            <a:rect l="l" t="t" r="r" b="b"/>
-            <a:pathLst>
-              <a:path w="647700" h="647700">
-                <a:moveTo>
-                  <a:pt x="323850" y="0"/>
-                </a:moveTo>
-                <a:cubicBezTo>
-                  <a:pt x="369570" y="278130"/>
-                  <a:pt x="369570" y="278130"/>
-                  <a:pt x="647700" y="323850"/>
-                </a:cubicBezTo>
-                <a:cubicBezTo>
-                  <a:pt x="369570" y="369570"/>
-                  <a:pt x="369570" y="369570"/>
-                  <a:pt x="323850" y="647700"/>
-                </a:cubicBezTo>
-                <a:cubicBezTo>
-                  <a:pt x="278130" y="369570"/>
-                  <a:pt x="278130" y="369570"/>
-                  <a:pt x="0" y="323850"/>
-                </a:cubicBezTo>
-                <a:cubicBezTo>
-                  <a:pt x="278130" y="278130"/>
-                  <a:pt x="278130" y="278130"/>
-                  <a:pt x="323850" y="0"/>
-                </a:cubicBezTo>
-                <a:close/>
-              </a:path>
-            </a:pathLst>
-          </a:custGeom>
-          <a:solidFill>
-            <a:srgbClr val="F0521E"/>
-          </a:solidFill>
-          <a:ln/>
-        </p:spPr>
-      </p:sp>
-      <p:sp>
-        <p:nvSpPr>
-          <p:cNvPr id="18" name=""/>
-          <p:cNvSpPr/>
-          <p:nvPr/>
-        </p:nvSpPr>
-        <p:spPr>
-          <a:xfrm>
-            <a:off x="2000250" y="5086350"/>
-            <a:ext cx="495300" cy="495300"/>
-          </a:xfrm>
-          <a:custGeom>
-            <a:avLst/>
-            <a:gdLst/>
-            <a:ahLst/>
-            <a:cxnLst/>
-            <a:rect l="l" t="t" r="r" b="b"/>
-            <a:pathLst>
-              <a:path w="495300" h="495300">
-                <a:moveTo>
-                  <a:pt x="247650" y="0"/>
-                </a:moveTo>
-                <a:cubicBezTo>
-                  <a:pt x="281940" y="213360"/>
-                  <a:pt x="281940" y="213360"/>
-                  <a:pt x="495300" y="247650"/>
-                </a:cubicBezTo>
-                <a:cubicBezTo>
-                  <a:pt x="281940" y="281940"/>
-                  <a:pt x="281940" y="281940"/>
-                  <a:pt x="247650" y="495300"/>
-                </a:cubicBezTo>
-                <a:cubicBezTo>
-                  <a:pt x="213360" y="281940"/>
-                  <a:pt x="213360" y="281940"/>
-                  <a:pt x="0" y="247650"/>
-                </a:cubicBezTo>
-                <a:cubicBezTo>
-                  <a:pt x="213360" y="213360"/>
-                  <a:pt x="213360" y="213360"/>
-                  <a:pt x="247650" y="0"/>
-                </a:cubicBezTo>
-                <a:close/>
-              </a:path>
-            </a:pathLst>
-          </a:custGeom>
-          <a:solidFill>
-            <a:srgbClr val="FFC94A"/>
-          </a:solidFill>
-          <a:ln/>
-        </p:spPr>
-      </p:sp>
-      <p:sp>
-        <p:nvSpPr>
-          <p:cNvPr id="19" name=""/>
-          <p:cNvSpPr/>
-          <p:nvPr/>
-        </p:nvSpPr>
-        <p:spPr>
-          <a:xfrm>
-            <a:off x="11144250" y="5238750"/>
-            <a:ext cx="304800" cy="304800"/>
-          </a:xfrm>
-          <a:custGeom>
-            <a:avLst/>
-            <a:gdLst/>
-            <a:ahLst/>
-            <a:cxnLst/>
-            <a:rect l="l" t="t" r="r" b="b"/>
-            <a:pathLst>
-              <a:path w="304800" h="304800">
-                <a:moveTo>
-                  <a:pt x="152400" y="0"/>
-                </a:moveTo>
-                <a:cubicBezTo>
-                  <a:pt x="173355" y="131445"/>
-                  <a:pt x="173355" y="131445"/>
-                  <a:pt x="304800" y="152400"/>
-                </a:cubicBezTo>
-                <a:cubicBezTo>
-                  <a:pt x="173355" y="173355"/>
-                  <a:pt x="173355" y="173355"/>
-                  <a:pt x="152400" y="304800"/>
-                </a:cubicBezTo>
-                <a:cubicBezTo>
-                  <a:pt x="131445" y="173355"/>
-                  <a:pt x="131445" y="173355"/>
-                  <a:pt x="0" y="152400"/>
-                </a:cubicBezTo>
-                <a:cubicBezTo>
-                  <a:pt x="131445" y="131445"/>
-                  <a:pt x="131445" y="131445"/>
-                  <a:pt x="152400" y="0"/>
-                </a:cubicBezTo>
-                <a:close/>
-              </a:path>
-            </a:pathLst>
-          </a:custGeom>
-          <a:solidFill>
-            <a:srgbClr val="7DBDEB"/>
-          </a:solidFill>
-          <a:ln/>
-        </p:spPr>
-      </p:sp>
-      <p:sp>
-        <p:nvSpPr>
-          <p:cNvPr id="20" name=""/>
-          <p:cNvSpPr/>
-          <p:nvPr/>
-        </p:nvSpPr>
-        <p:spPr>
-          <a:xfrm>
-            <a:off x="1009650" y="2095500"/>
-            <a:ext cx="304800" cy="304800"/>
-          </a:xfrm>
-          <a:custGeom>
-            <a:avLst/>
-            <a:gdLst/>
-            <a:ahLst/>
-            <a:cxnLst/>
-            <a:rect l="l" t="t" r="r" b="b"/>
-            <a:pathLst>
-              <a:path w="304800" h="304800">
-                <a:moveTo>
-                  <a:pt x="152400" y="0"/>
-                </a:moveTo>
-                <a:cubicBezTo>
-                  <a:pt x="173355" y="131445"/>
-                  <a:pt x="173355" y="131445"/>
-                  <a:pt x="304800" y="152400"/>
-                </a:cubicBezTo>
-                <a:cubicBezTo>
-                  <a:pt x="173355" y="173355"/>
-                  <a:pt x="173355" y="173355"/>
-                  <a:pt x="152400" y="304800"/>
-                </a:cubicBezTo>
-                <a:cubicBezTo>
-                  <a:pt x="131445" y="173355"/>
-                  <a:pt x="131445" y="173355"/>
-                  <a:pt x="0" y="152400"/>
-                </a:cubicBezTo>
-                <a:cubicBezTo>
-                  <a:pt x="131445" y="131445"/>
-                  <a:pt x="131445" y="131445"/>
-                  <a:pt x="152400" y="0"/>
-                </a:cubicBezTo>
-                <a:close/>
-              </a:path>
-            </a:pathLst>
-          </a:custGeom>
-          <a:solidFill>
-            <a:srgbClr val="FF9DB4"/>
+            <a:srgbClr val="FFD24A"/>
           </a:solidFill>
           <a:ln/>
         </p:spPr>

</xml_diff>